<commit_message>
docs: update PPT with latest features - multi-model, custom data upload, dynamic quick questions
</commit_message>
<xml_diff>
--- a/docs/NL2SQL_答辩PPT.pptx
+++ b/docs/NL2SQL_答辩PPT.pptx
@@ -4130,7 +4130,7 @@
               </a:defRPr>
             </a:pPr>
             <a:r>
-              <a:t>系统演示 - 3 个典型场景</a:t>
+              <a:t>系统演示 - 4 个典型场景</a:t>
             </a:r>
           </a:p>
         </p:txBody>
@@ -4221,8 +4221,8 @@
         </p:nvSpPr>
         <p:spPr>
           <a:xfrm>
-            <a:off x="457200" y="1554480"/>
-            <a:ext cx="3566160" cy="2926080"/>
+            <a:off x="182880" y="1554480"/>
+            <a:ext cx="2743200" cy="2926080"/>
           </a:xfrm>
           <a:prstGeom prst="roundRect">
             <a:avLst/>
@@ -4266,8 +4266,8 @@
         </p:nvSpPr>
         <p:spPr>
           <a:xfrm>
-            <a:off x="731520" y="1737360"/>
-            <a:ext cx="3017520" cy="365760"/>
+            <a:off x="457200" y="1737360"/>
+            <a:ext cx="2194560" cy="365760"/>
           </a:xfrm>
           <a:prstGeom prst="rect">
             <a:avLst/>
@@ -4301,8 +4301,8 @@
         </p:nvSpPr>
         <p:spPr>
           <a:xfrm>
-            <a:off x="731520" y="2103120"/>
-            <a:ext cx="3017520" cy="2194560"/>
+            <a:off x="457200" y="2103120"/>
+            <a:ext cx="2194560" cy="2194560"/>
           </a:xfrm>
           <a:prstGeom prst="rect">
             <a:avLst/>
@@ -4399,8 +4399,8 @@
         </p:nvSpPr>
         <p:spPr>
           <a:xfrm>
-            <a:off x="4297680" y="1554480"/>
-            <a:ext cx="3566160" cy="2926080"/>
+            <a:off x="3154680" y="1554480"/>
+            <a:ext cx="2743200" cy="2926080"/>
           </a:xfrm>
           <a:prstGeom prst="roundRect">
             <a:avLst/>
@@ -4444,8 +4444,8 @@
         </p:nvSpPr>
         <p:spPr>
           <a:xfrm>
-            <a:off x="4572000" y="1737360"/>
-            <a:ext cx="3017520" cy="365760"/>
+            <a:off x="3429000" y="1737360"/>
+            <a:ext cx="2194560" cy="365760"/>
           </a:xfrm>
           <a:prstGeom prst="rect">
             <a:avLst/>
@@ -4479,8 +4479,8 @@
         </p:nvSpPr>
         <p:spPr>
           <a:xfrm>
-            <a:off x="4572000" y="2103120"/>
-            <a:ext cx="3017520" cy="2194560"/>
+            <a:off x="3429000" y="2103120"/>
+            <a:ext cx="2194560" cy="2194560"/>
           </a:xfrm>
           <a:prstGeom prst="rect">
             <a:avLst/>
@@ -4577,8 +4577,8 @@
         </p:nvSpPr>
         <p:spPr>
           <a:xfrm>
-            <a:off x="8138160" y="1554480"/>
-            <a:ext cx="3566160" cy="2926080"/>
+            <a:off x="6126480" y="1554480"/>
+            <a:ext cx="2743200" cy="2926080"/>
           </a:xfrm>
           <a:prstGeom prst="roundRect">
             <a:avLst/>
@@ -4622,8 +4622,8 @@
         </p:nvSpPr>
         <p:spPr>
           <a:xfrm>
-            <a:off x="8412480" y="1737360"/>
-            <a:ext cx="3017520" cy="365760"/>
+            <a:off x="6400800" y="1737360"/>
+            <a:ext cx="2194560" cy="365760"/>
           </a:xfrm>
           <a:prstGeom prst="rect">
             <a:avLst/>
@@ -4657,8 +4657,8 @@
         </p:nvSpPr>
         <p:spPr>
           <a:xfrm>
-            <a:off x="8412480" y="2103120"/>
-            <a:ext cx="3017520" cy="2194560"/>
+            <a:off x="6400800" y="2103120"/>
+            <a:ext cx="2194560" cy="2194560"/>
           </a:xfrm>
           <a:prstGeom prst="rect">
             <a:avLst/>
@@ -4755,8 +4755,8 @@
         </p:nvSpPr>
         <p:spPr>
           <a:xfrm>
-            <a:off x="914400" y="5029200"/>
-            <a:ext cx="1645920" cy="1188720"/>
+            <a:off x="9098280" y="1554480"/>
+            <a:ext cx="2743200" cy="2926080"/>
           </a:xfrm>
           <a:prstGeom prst="roundRect">
             <a:avLst/>
@@ -4800,29 +4800,29 @@
         </p:nvSpPr>
         <p:spPr>
           <a:xfrm>
-            <a:off x="914400" y="5166360"/>
-            <a:ext cx="1645920" cy="548640"/>
-          </a:xfrm>
-          <a:prstGeom prst="rect">
-            <a:avLst/>
-          </a:prstGeom>
-          <a:noFill/>
-        </p:spPr>
-        <p:txBody>
-          <a:bodyPr wrap="square">
-            <a:spAutoFit/>
-          </a:bodyPr>
-          <a:lstStyle/>
-          <a:p>
-            <a:pPr algn="ctr">
-              <a:defRPr sz="2600" b="1">
-                <a:solidFill>
-                  <a:srgbClr val="10B981"/>
-                </a:solidFill>
-              </a:defRPr>
-            </a:pPr>
-            <a:r>
-              <a:t>3-5秒</a:t>
+            <a:off x="9372600" y="1737360"/>
+            <a:ext cx="2194560" cy="365760"/>
+          </a:xfrm>
+          <a:prstGeom prst="rect">
+            <a:avLst/>
+          </a:prstGeom>
+          <a:noFill/>
+        </p:spPr>
+        <p:txBody>
+          <a:bodyPr wrap="square">
+            <a:spAutoFit/>
+          </a:bodyPr>
+          <a:lstStyle/>
+          <a:p>
+            <a:pPr algn="l">
+              <a:defRPr sz="1500" b="1">
+                <a:solidFill>
+                  <a:srgbClr val="0D2B5E"/>
+                </a:solidFill>
+              </a:defRPr>
+            </a:pPr>
+            <a:r>
+              <a:t>场景4:自定义数据上传</a:t>
             </a:r>
           </a:p>
         </p:txBody>
@@ -4835,29 +4835,92 @@
         </p:nvSpPr>
         <p:spPr>
           <a:xfrm>
-            <a:off x="914400" y="5760720"/>
-            <a:ext cx="1645920" cy="320040"/>
-          </a:xfrm>
-          <a:prstGeom prst="rect">
-            <a:avLst/>
-          </a:prstGeom>
-          <a:noFill/>
-        </p:spPr>
-        <p:txBody>
-          <a:bodyPr wrap="square">
-            <a:spAutoFit/>
-          </a:bodyPr>
-          <a:lstStyle/>
-          <a:p>
-            <a:pPr algn="ctr">
-              <a:defRPr sz="900" b="0">
-                <a:solidFill>
-                  <a:srgbClr val="94A3B8"/>
-                </a:solidFill>
-              </a:defRPr>
-            </a:pPr>
-            <a:r>
-              <a:t>平均响应</a:t>
+            <a:off x="9372600" y="2103120"/>
+            <a:ext cx="2194560" cy="2194560"/>
+          </a:xfrm>
+          <a:prstGeom prst="rect">
+            <a:avLst/>
+          </a:prstGeom>
+          <a:noFill/>
+        </p:spPr>
+        <p:txBody>
+          <a:bodyPr wrap="square">
+            <a:spAutoFit/>
+          </a:bodyPr>
+          <a:lstStyle/>
+          <a:p>
+            <a:pPr>
+              <a:spcAft>
+                <a:spcPts val="400"/>
+              </a:spcAft>
+              <a:defRPr sz="1100">
+                <a:solidFill>
+                  <a:srgbClr val="334055"/>
+                </a:solidFill>
+              </a:defRPr>
+            </a:pPr>
+            <a:r>
+              <a:t>上传:拖入CSV/Excel员工表/销售表</a:t>
+            </a:r>
+          </a:p>
+          <a:p>
+            <a:pPr>
+              <a:spcAft>
+                <a:spcPts val="400"/>
+              </a:spcAft>
+              <a:defRPr sz="1100">
+                <a:solidFill>
+                  <a:srgbClr val="334055"/>
+                </a:solidFill>
+              </a:defRPr>
+            </a:pPr>
+            <a:r>
+              <a:t>自动:建表+Schema生成+快捷问题</a:t>
+            </a:r>
+          </a:p>
+          <a:p>
+            <a:pPr>
+              <a:spcAft>
+                <a:spcPts val="400"/>
+              </a:spcAft>
+              <a:defRPr sz="1100">
+                <a:solidFill>
+                  <a:srgbClr val="334055"/>
+                </a:solidFill>
+              </a:defRPr>
+            </a:pPr>
+            <a:r>
+              <a:t>提问:员工平均薪资?各部门人数?</a:t>
+            </a:r>
+          </a:p>
+          <a:p>
+            <a:pPr>
+              <a:spcAft>
+                <a:spcPts val="400"/>
+              </a:spcAft>
+              <a:defRPr sz="1100">
+                <a:solidFill>
+                  <a:srgbClr val="334055"/>
+                </a:solidFill>
+              </a:defRPr>
+            </a:pPr>
+            <a:r>
+              <a:t>AI解读:基于任意上传数据智能分析</a:t>
+            </a:r>
+          </a:p>
+          <a:p>
+            <a:pPr>
+              <a:spcAft>
+                <a:spcPts val="400"/>
+              </a:spcAft>
+              <a:defRPr sz="1100">
+                <a:solidFill>
+                  <a:srgbClr val="334055"/>
+                </a:solidFill>
+              </a:defRPr>
+            </a:pPr>
+            <a:r>
+              <a:t>响应:4.0秒</a:t>
             </a:r>
           </a:p>
         </p:txBody>
@@ -4870,7 +4933,7 @@
         </p:nvSpPr>
         <p:spPr>
           <a:xfrm>
-            <a:off x="3749039" y="5029200"/>
+            <a:off x="914400" y="5029200"/>
             <a:ext cx="1645920" cy="1188720"/>
           </a:xfrm>
           <a:prstGeom prst="roundRect">
@@ -4915,7 +4978,7 @@
         </p:nvSpPr>
         <p:spPr>
           <a:xfrm>
-            <a:off x="3749039" y="5166360"/>
+            <a:off x="914400" y="5166360"/>
             <a:ext cx="1645920" cy="548640"/>
           </a:xfrm>
           <a:prstGeom prst="rect">
@@ -4937,7 +5000,7 @@
               </a:defRPr>
             </a:pPr>
             <a:r>
-              <a:t>88%</a:t>
+              <a:t>3-5秒</a:t>
             </a:r>
           </a:p>
         </p:txBody>
@@ -4950,7 +5013,7 @@
         </p:nvSpPr>
         <p:spPr>
           <a:xfrm>
-            <a:off x="3749039" y="5760720"/>
+            <a:off x="914400" y="5760720"/>
             <a:ext cx="1645920" cy="320040"/>
           </a:xfrm>
           <a:prstGeom prst="rect">
@@ -4972,7 +5035,7 @@
               </a:defRPr>
             </a:pPr>
             <a:r>
-              <a:t>SQL准确率</a:t>
+              <a:t>平均响应</a:t>
             </a:r>
           </a:p>
         </p:txBody>
@@ -4985,7 +5048,7 @@
         </p:nvSpPr>
         <p:spPr>
           <a:xfrm>
-            <a:off x="6583680" y="5029200"/>
+            <a:off x="3749039" y="5029200"/>
             <a:ext cx="1645920" cy="1188720"/>
           </a:xfrm>
           <a:prstGeom prst="roundRect">
@@ -5030,7 +5093,7 @@
         </p:nvSpPr>
         <p:spPr>
           <a:xfrm>
-            <a:off x="6583680" y="5166360"/>
+            <a:off x="3749039" y="5166360"/>
             <a:ext cx="1645920" cy="548640"/>
           </a:xfrm>
           <a:prstGeom prst="rect">
@@ -5052,7 +5115,7 @@
               </a:defRPr>
             </a:pPr>
             <a:r>
-              <a:t>80%+</a:t>
+              <a:t>88%</a:t>
             </a:r>
           </a:p>
         </p:txBody>
@@ -5065,7 +5128,7 @@
         </p:nvSpPr>
         <p:spPr>
           <a:xfrm>
-            <a:off x="6583680" y="5760720"/>
+            <a:off x="3749039" y="5760720"/>
             <a:ext cx="1645920" cy="320040"/>
           </a:xfrm>
           <a:prstGeom prst="rect">
@@ -5087,7 +5150,7 @@
               </a:defRPr>
             </a:pPr>
             <a:r>
-              <a:t>纠错成功率</a:t>
+              <a:t>SQL准确率</a:t>
             </a:r>
           </a:p>
         </p:txBody>
@@ -5100,7 +5163,7 @@
         </p:nvSpPr>
         <p:spPr>
           <a:xfrm>
-            <a:off x="9418320" y="5029200"/>
+            <a:off x="6583680" y="5029200"/>
             <a:ext cx="1645920" cy="1188720"/>
           </a:xfrm>
           <a:prstGeom prst="roundRect">
@@ -5145,6 +5208,121 @@
         </p:nvSpPr>
         <p:spPr>
           <a:xfrm>
+            <a:off x="6583680" y="5166360"/>
+            <a:ext cx="1645920" cy="548640"/>
+          </a:xfrm>
+          <a:prstGeom prst="rect">
+            <a:avLst/>
+          </a:prstGeom>
+          <a:noFill/>
+        </p:spPr>
+        <p:txBody>
+          <a:bodyPr wrap="square">
+            <a:spAutoFit/>
+          </a:bodyPr>
+          <a:lstStyle/>
+          <a:p>
+            <a:pPr algn="ctr">
+              <a:defRPr sz="2600" b="1">
+                <a:solidFill>
+                  <a:srgbClr val="10B981"/>
+                </a:solidFill>
+              </a:defRPr>
+            </a:pPr>
+            <a:r>
+              <a:t>80%+</a:t>
+            </a:r>
+          </a:p>
+        </p:txBody>
+      </p:sp>
+      <p:sp>
+        <p:nvSpPr>
+          <p:cNvPr id="28" name="TextBox 27"/>
+          <p:cNvSpPr txBox="1"/>
+          <p:nvPr/>
+        </p:nvSpPr>
+        <p:spPr>
+          <a:xfrm>
+            <a:off x="6583680" y="5760720"/>
+            <a:ext cx="1645920" cy="320040"/>
+          </a:xfrm>
+          <a:prstGeom prst="rect">
+            <a:avLst/>
+          </a:prstGeom>
+          <a:noFill/>
+        </p:spPr>
+        <p:txBody>
+          <a:bodyPr wrap="square">
+            <a:spAutoFit/>
+          </a:bodyPr>
+          <a:lstStyle/>
+          <a:p>
+            <a:pPr algn="ctr">
+              <a:defRPr sz="900" b="0">
+                <a:solidFill>
+                  <a:srgbClr val="94A3B8"/>
+                </a:solidFill>
+              </a:defRPr>
+            </a:pPr>
+            <a:r>
+              <a:t>纠错成功率</a:t>
+            </a:r>
+          </a:p>
+        </p:txBody>
+      </p:sp>
+      <p:sp>
+        <p:nvSpPr>
+          <p:cNvPr id="29" name="Rounded Rectangle 28"/>
+          <p:cNvSpPr/>
+          <p:nvPr/>
+        </p:nvSpPr>
+        <p:spPr>
+          <a:xfrm>
+            <a:off x="9418320" y="5029200"/>
+            <a:ext cx="1645920" cy="1188720"/>
+          </a:xfrm>
+          <a:prstGeom prst="roundRect">
+            <a:avLst/>
+          </a:prstGeom>
+          <a:solidFill>
+            <a:srgbClr val="FFFFFF"/>
+          </a:solidFill>
+          <a:ln w="12700">
+            <a:solidFill>
+              <a:srgbClr val="E2E8F0"/>
+            </a:solidFill>
+          </a:ln>
+        </p:spPr>
+        <p:style>
+          <a:lnRef idx="1">
+            <a:schemeClr val="accent1"/>
+          </a:lnRef>
+          <a:fillRef idx="3">
+            <a:schemeClr val="accent1"/>
+          </a:fillRef>
+          <a:effectRef idx="2">
+            <a:schemeClr val="accent1"/>
+          </a:effectRef>
+          <a:fontRef idx="minor">
+            <a:schemeClr val="lt1"/>
+          </a:fontRef>
+        </p:style>
+        <p:txBody>
+          <a:bodyPr rtlCol="0" anchor="ctr"/>
+          <a:lstStyle/>
+          <a:p>
+            <a:pPr algn="ctr"/>
+          </a:p>
+        </p:txBody>
+      </p:sp>
+      <p:sp>
+        <p:nvSpPr>
+          <p:cNvPr id="30" name="TextBox 29"/>
+          <p:cNvSpPr txBox="1"/>
+          <p:nvPr/>
+        </p:nvSpPr>
+        <p:spPr>
+          <a:xfrm>
             <a:off x="9418320" y="5166360"/>
             <a:ext cx="1645920" cy="548640"/>
           </a:xfrm>
@@ -5167,14 +5345,14 @@
               </a:defRPr>
             </a:pPr>
             <a:r>
-              <a:t>20+</a:t>
-            </a:r>
-          </a:p>
-        </p:txBody>
-      </p:sp>
-      <p:sp>
-        <p:nvSpPr>
-          <p:cNvPr id="28" name="TextBox 27"/>
+              <a:t>自定义</a:t>
+            </a:r>
+          </a:p>
+        </p:txBody>
+      </p:sp>
+      <p:sp>
+        <p:nvSpPr>
+          <p:cNvPr id="31" name="TextBox 30"/>
           <p:cNvSpPr txBox="1"/>
           <p:nvPr/>
         </p:nvSpPr>
@@ -5202,7 +5380,7 @@
               </a:defRPr>
             </a:pPr>
             <a:r>
-              <a:t>问数场景</a:t>
+              <a:t>数据即插即用</a:t>
             </a:r>
           </a:p>
         </p:txBody>
@@ -9953,7 +10131,7 @@
         <p:spPr>
           <a:xfrm>
             <a:off x="731520" y="1645920"/>
-            <a:ext cx="10698480" cy="1051560"/>
+            <a:ext cx="10698480" cy="822960"/>
           </a:xfrm>
           <a:prstGeom prst="roundRect">
             <a:avLst/>
@@ -10085,8 +10263,8 @@
         </p:nvSpPr>
         <p:spPr>
           <a:xfrm>
-            <a:off x="731520" y="2880360"/>
-            <a:ext cx="10698480" cy="1051560"/>
+            <a:off x="731520" y="2606040"/>
+            <a:ext cx="10698480" cy="822960"/>
           </a:xfrm>
           <a:prstGeom prst="roundRect">
             <a:avLst/>
@@ -10130,7 +10308,7 @@
         </p:nvSpPr>
         <p:spPr>
           <a:xfrm>
-            <a:off x="1005840" y="2953512"/>
+            <a:off x="1005840" y="2679192"/>
             <a:ext cx="2743200" cy="457200"/>
           </a:xfrm>
           <a:prstGeom prst="rect">
@@ -10165,7 +10343,7 @@
         </p:nvSpPr>
         <p:spPr>
           <a:xfrm>
-            <a:off x="1005840" y="3383280"/>
+            <a:off x="1005840" y="3108960"/>
             <a:ext cx="9601200" cy="548640"/>
           </a:xfrm>
           <a:prstGeom prst="rect">
@@ -10218,8 +10396,8 @@
         </p:nvSpPr>
         <p:spPr>
           <a:xfrm>
-            <a:off x="731520" y="4114800"/>
-            <a:ext cx="10698480" cy="1051560"/>
+            <a:off x="731520" y="3566160"/>
+            <a:ext cx="10698480" cy="822960"/>
           </a:xfrm>
           <a:prstGeom prst="roundRect">
             <a:avLst/>
@@ -10263,7 +10441,7 @@
         </p:nvSpPr>
         <p:spPr>
           <a:xfrm>
-            <a:off x="1005840" y="4187952"/>
+            <a:off x="1005840" y="3639312"/>
             <a:ext cx="2743200" cy="457200"/>
           </a:xfrm>
           <a:prstGeom prst="rect">
@@ -10298,7 +10476,7 @@
         </p:nvSpPr>
         <p:spPr>
           <a:xfrm>
-            <a:off x="1005840" y="4617720"/>
+            <a:off x="1005840" y="4069080"/>
             <a:ext cx="9601200" cy="548640"/>
           </a:xfrm>
           <a:prstGeom prst="rect">
@@ -10351,8 +10529,8 @@
         </p:nvSpPr>
         <p:spPr>
           <a:xfrm>
-            <a:off x="731520" y="5349240"/>
-            <a:ext cx="10698480" cy="1051560"/>
+            <a:off x="731520" y="4526280"/>
+            <a:ext cx="10698480" cy="822960"/>
           </a:xfrm>
           <a:prstGeom prst="roundRect">
             <a:avLst/>
@@ -10396,7 +10574,7 @@
         </p:nvSpPr>
         <p:spPr>
           <a:xfrm>
-            <a:off x="1005840" y="5422392"/>
+            <a:off x="1005840" y="4599432"/>
             <a:ext cx="2743200" cy="457200"/>
           </a:xfrm>
           <a:prstGeom prst="rect">
@@ -10431,7 +10609,7 @@
         </p:nvSpPr>
         <p:spPr>
           <a:xfrm>
-            <a:off x="1005840" y="5852160"/>
+            <a:off x="1005840" y="5029200"/>
             <a:ext cx="9601200" cy="548640"/>
           </a:xfrm>
           <a:prstGeom prst="rect">
@@ -11192,6 +11370,122 @@
           </a:p>
         </p:txBody>
       </p:sp>
+      <p:sp>
+        <p:nvSpPr>
+          <p:cNvPr id="20" name="Rounded Rectangle 19"/>
+          <p:cNvSpPr/>
+          <p:nvPr/>
+        </p:nvSpPr>
+        <p:spPr>
+          <a:xfrm>
+            <a:off x="731520" y="6126480"/>
+            <a:ext cx="10698480" cy="960120"/>
+          </a:xfrm>
+          <a:prstGeom prst="roundRect">
+            <a:avLst/>
+          </a:prstGeom>
+          <a:solidFill>
+            <a:srgbClr val="E8F0FE"/>
+          </a:solidFill>
+          <a:ln>
+            <a:noFill/>
+          </a:ln>
+        </p:spPr>
+        <p:style>
+          <a:lnRef idx="1">
+            <a:schemeClr val="accent1"/>
+          </a:lnRef>
+          <a:fillRef idx="3">
+            <a:schemeClr val="accent1"/>
+          </a:fillRef>
+          <a:effectRef idx="2">
+            <a:schemeClr val="accent1"/>
+          </a:effectRef>
+          <a:fontRef idx="minor">
+            <a:schemeClr val="lt1"/>
+          </a:fontRef>
+        </p:style>
+        <p:txBody>
+          <a:bodyPr rtlCol="0" anchor="ctr"/>
+          <a:lstStyle/>
+          <a:p>
+            <a:pPr algn="ctr"/>
+          </a:p>
+        </p:txBody>
+      </p:sp>
+      <p:sp>
+        <p:nvSpPr>
+          <p:cNvPr id="21" name="TextBox 20"/>
+          <p:cNvSpPr txBox="1"/>
+          <p:nvPr/>
+        </p:nvSpPr>
+        <p:spPr>
+          <a:xfrm>
+            <a:off x="1005840" y="6217920"/>
+            <a:ext cx="9144000" cy="292608"/>
+          </a:xfrm>
+          <a:prstGeom prst="rect">
+            <a:avLst/>
+          </a:prstGeom>
+          <a:noFill/>
+        </p:spPr>
+        <p:txBody>
+          <a:bodyPr wrap="square">
+            <a:spAutoFit/>
+          </a:bodyPr>
+          <a:lstStyle/>
+          <a:p>
+            <a:pPr algn="l">
+              <a:defRPr sz="1500" b="1">
+                <a:solidFill>
+                  <a:srgbClr val="0D2B5E"/>
+                </a:solidFill>
+              </a:defRPr>
+            </a:pPr>
+            <a:r>
+              <a:t>自定义数据即插即用</a:t>
+            </a:r>
+          </a:p>
+        </p:txBody>
+      </p:sp>
+      <p:sp>
+        <p:nvSpPr>
+          <p:cNvPr id="22" name="TextBox 21"/>
+          <p:cNvSpPr txBox="1"/>
+          <p:nvPr/>
+        </p:nvSpPr>
+        <p:spPr>
+          <a:xfrm>
+            <a:off x="1005840" y="6565392"/>
+            <a:ext cx="9601200" cy="502920"/>
+          </a:xfrm>
+          <a:prstGeom prst="rect">
+            <a:avLst/>
+          </a:prstGeom>
+          <a:noFill/>
+        </p:spPr>
+        <p:txBody>
+          <a:bodyPr wrap="square">
+            <a:spAutoFit/>
+          </a:bodyPr>
+          <a:lstStyle/>
+          <a:p>
+            <a:pPr>
+              <a:spcAft>
+                <a:spcPts val="600"/>
+              </a:spcAft>
+              <a:defRPr sz="1100">
+                <a:solidFill>
+                  <a:srgbClr val="334055"/>
+                </a:solidFill>
+              </a:defRPr>
+            </a:pPr>
+            <a:r>
+              <a:t>上传CSV/Excel自动建表动态Schema生成表名白名单注入一键分析任意数据</a:t>
+            </a:r>
+          </a:p>
+        </p:txBody>
+      </p:sp>
     </p:spTree>
   </p:cSld>
   <p:clrMapOvr>
@@ -12667,7 +12961,22 @@
               </a:defRPr>
             </a:pPr>
             <a:r>
-              <a:t>赛道：经营分析  |  AI 工具：DeepSeek-V4</a:t>
+              <a:t>多模型: DeepSeek-V4 / Qwen / GPT-4o</a:t>
+            </a:r>
+          </a:p>
+          <a:p>
+            <a:pPr algn="ctr">
+              <a:spcAft>
+                <a:spcPts val="800"/>
+              </a:spcAft>
+              <a:defRPr sz="1300">
+                <a:solidFill>
+                  <a:srgbClr val="FFFFFF"/>
+                </a:solidFill>
+              </a:defRPr>
+            </a:pPr>
+            <a:r>
+              <a:t>支持: 演示数据 + CSV/Excel自定义上传</a:t>
             </a:r>
           </a:p>
           <a:p>
@@ -16530,7 +16839,42 @@
       </p:sp>
       <p:sp>
         <p:nvSpPr>
-          <p:cNvPr id="16" name="Rounded Rectangle 15"/>
+          <p:cNvPr id="16" name="TextBox 15"/>
+          <p:cNvSpPr txBox="1"/>
+          <p:nvPr/>
+        </p:nvSpPr>
+        <p:spPr>
+          <a:xfrm>
+            <a:off x="1005840" y="4133088"/>
+            <a:ext cx="10058400" cy="274320"/>
+          </a:xfrm>
+          <a:prstGeom prst="rect">
+            <a:avLst/>
+          </a:prstGeom>
+          <a:noFill/>
+        </p:spPr>
+        <p:txBody>
+          <a:bodyPr wrap="square">
+            <a:spAutoFit/>
+          </a:bodyPr>
+          <a:lstStyle/>
+          <a:p>
+            <a:pPr algn="l">
+              <a:defRPr sz="1000" b="0">
+                <a:solidFill>
+                  <a:srgbClr val="E0E8F0"/>
+                </a:solidFill>
+              </a:defRPr>
+            </a:pPr>
+            <a:r>
+              <a:t>多模型支持: DeepSeek-V4 / Qwen / GPT-4o 一键切换</a:t>
+            </a:r>
+          </a:p>
+        </p:txBody>
+      </p:sp>
+      <p:sp>
+        <p:nvSpPr>
+          <p:cNvPr id="17" name="Rounded Rectangle 16"/>
           <p:cNvSpPr/>
           <p:nvPr/>
         </p:nvSpPr>
@@ -16573,7 +16917,7 @@
       </p:sp>
       <p:sp>
         <p:nvSpPr>
-          <p:cNvPr id="17" name="TextBox 16"/>
+          <p:cNvPr id="18" name="TextBox 17"/>
           <p:cNvSpPr txBox="1"/>
           <p:nvPr/>
         </p:nvSpPr>
@@ -16601,14 +16945,14 @@
               </a:defRPr>
             </a:pPr>
             <a:r>
-              <a:t>数据层 SQLite / 星型模型</a:t>
-            </a:r>
-          </a:p>
-        </p:txBody>
-      </p:sp>
-      <p:sp>
-        <p:nvSpPr>
-          <p:cNvPr id="18" name="TextBox 17"/>
+              <a:t>数据层 SQLite / 自定义上传</a:t>
+            </a:r>
+          </a:p>
+        </p:txBody>
+      </p:sp>
+      <p:sp>
+        <p:nvSpPr>
+          <p:cNvPr id="19" name="TextBox 18"/>
           <p:cNvSpPr txBox="1"/>
           <p:nvPr/>
         </p:nvSpPr>
@@ -16636,14 +16980,14 @@
               </a:defRPr>
             </a:pPr>
             <a:r>
-              <a:t>6 维度表 + 5 事实表</a:t>
-            </a:r>
-          </a:p>
-        </p:txBody>
-      </p:sp>
-      <p:sp>
-        <p:nvSpPr>
-          <p:cNvPr id="19" name="TextBox 18"/>
+              <a:t>6 维度表 + 5 事实表(演示数据)</a:t>
+            </a:r>
+          </a:p>
+        </p:txBody>
+      </p:sp>
+      <p:sp>
+        <p:nvSpPr>
+          <p:cNvPr id="20" name="TextBox 19"/>
           <p:cNvSpPr txBox="1"/>
           <p:nvPr/>
         </p:nvSpPr>
@@ -16671,6 +17015,41 @@
               </a:defRPr>
             </a:pPr>
             <a:r>
+              <a:t>支持 CSV/Excel 文件上传 自动建表自动分析</a:t>
+            </a:r>
+          </a:p>
+        </p:txBody>
+      </p:sp>
+      <p:sp>
+        <p:nvSpPr>
+          <p:cNvPr id="21" name="TextBox 20"/>
+          <p:cNvSpPr txBox="1"/>
+          <p:nvPr/>
+        </p:nvSpPr>
+        <p:spPr>
+          <a:xfrm>
+            <a:off x="1005840" y="5596128"/>
+            <a:ext cx="10058400" cy="274320"/>
+          </a:xfrm>
+          <a:prstGeom prst="rect">
+            <a:avLst/>
+          </a:prstGeom>
+          <a:noFill/>
+        </p:spPr>
+        <p:txBody>
+          <a:bodyPr wrap="square">
+            <a:spAutoFit/>
+          </a:bodyPr>
+          <a:lstStyle/>
+          <a:p>
+            <a:pPr algn="l">
+              <a:defRPr sz="1000" b="0">
+                <a:solidFill>
+                  <a:srgbClr val="E0E8F0"/>
+                </a:solidFill>
+              </a:defRPr>
+            </a:pPr>
+            <a:r>
               <a:t>销售 | 成本 | 费用(含预算) | 应收 | 应付</a:t>
             </a:r>
           </a:p>
@@ -16678,7 +17057,7 @@
       </p:sp>
       <p:sp>
         <p:nvSpPr>
-          <p:cNvPr id="20" name="Rounded Rectangle 19"/>
+          <p:cNvPr id="22" name="Rounded Rectangle 21"/>
           <p:cNvSpPr/>
           <p:nvPr/>
         </p:nvSpPr>
@@ -16723,7 +17102,7 @@
       </p:sp>
       <p:sp>
         <p:nvSpPr>
-          <p:cNvPr id="21" name="TextBox 20"/>
+          <p:cNvPr id="23" name="TextBox 22"/>
           <p:cNvSpPr txBox="1"/>
           <p:nvPr/>
         </p:nvSpPr>
@@ -16758,7 +17137,7 @@
       </p:sp>
       <p:sp>
         <p:nvSpPr>
-          <p:cNvPr id="22" name="TextBox 21"/>
+          <p:cNvPr id="24" name="TextBox 23"/>
           <p:cNvSpPr txBox="1"/>
           <p:nvPr/>
         </p:nvSpPr>
@@ -16786,14 +17165,14 @@
               </a:defRPr>
             </a:pPr>
             <a:r>
-              <a:t>数据表</a:t>
-            </a:r>
-          </a:p>
-        </p:txBody>
-      </p:sp>
-      <p:sp>
-        <p:nvSpPr>
-          <p:cNvPr id="23" name="Rounded Rectangle 22"/>
+              <a:t>演示数据表</a:t>
+            </a:r>
+          </a:p>
+        </p:txBody>
+      </p:sp>
+      <p:sp>
+        <p:nvSpPr>
+          <p:cNvPr id="25" name="Rounded Rectangle 24"/>
           <p:cNvSpPr/>
           <p:nvPr/>
         </p:nvSpPr>
@@ -16838,7 +17217,7 @@
       </p:sp>
       <p:sp>
         <p:nvSpPr>
-          <p:cNvPr id="24" name="TextBox 23"/>
+          <p:cNvPr id="26" name="TextBox 25"/>
           <p:cNvSpPr txBox="1"/>
           <p:nvPr/>
         </p:nvSpPr>
@@ -16873,7 +17252,7 @@
       </p:sp>
       <p:sp>
         <p:nvSpPr>
-          <p:cNvPr id="25" name="TextBox 24"/>
+          <p:cNvPr id="27" name="TextBox 26"/>
           <p:cNvSpPr txBox="1"/>
           <p:nvPr/>
         </p:nvSpPr>
@@ -16901,14 +17280,14 @@
               </a:defRPr>
             </a:pPr>
             <a:r>
-              <a:t>总记录</a:t>
-            </a:r>
-          </a:p>
-        </p:txBody>
-      </p:sp>
-      <p:sp>
-        <p:nvSpPr>
-          <p:cNvPr id="26" name="Rounded Rectangle 25"/>
+              <a:t>演示总记录</a:t>
+            </a:r>
+          </a:p>
+        </p:txBody>
+      </p:sp>
+      <p:sp>
+        <p:nvSpPr>
+          <p:cNvPr id="28" name="Rounded Rectangle 27"/>
           <p:cNvSpPr/>
           <p:nvPr/>
         </p:nvSpPr>
@@ -16953,7 +17332,7 @@
       </p:sp>
       <p:sp>
         <p:nvSpPr>
-          <p:cNvPr id="27" name="TextBox 26"/>
+          <p:cNvPr id="29" name="TextBox 28"/>
           <p:cNvSpPr txBox="1"/>
           <p:nvPr/>
         </p:nvSpPr>
@@ -16988,7 +17367,7 @@
       </p:sp>
       <p:sp>
         <p:nvSpPr>
-          <p:cNvPr id="28" name="TextBox 27"/>
+          <p:cNvPr id="30" name="TextBox 29"/>
           <p:cNvSpPr txBox="1"/>
           <p:nvPr/>
         </p:nvSpPr>
@@ -17023,7 +17402,7 @@
       </p:sp>
       <p:sp>
         <p:nvSpPr>
-          <p:cNvPr id="29" name="Rounded Rectangle 28"/>
+          <p:cNvPr id="31" name="Rounded Rectangle 30"/>
           <p:cNvSpPr/>
           <p:nvPr/>
         </p:nvSpPr>
@@ -17068,7 +17447,7 @@
       </p:sp>
       <p:sp>
         <p:nvSpPr>
-          <p:cNvPr id="30" name="TextBox 29"/>
+          <p:cNvPr id="32" name="TextBox 31"/>
           <p:cNvSpPr txBox="1"/>
           <p:nvPr/>
         </p:nvSpPr>
@@ -17103,7 +17482,7 @@
       </p:sp>
       <p:sp>
         <p:nvSpPr>
-          <p:cNvPr id="31" name="TextBox 30"/>
+          <p:cNvPr id="33" name="TextBox 32"/>
           <p:cNvSpPr txBox="1"/>
           <p:nvPr/>
         </p:nvSpPr>
@@ -17138,7 +17517,7 @@
       </p:sp>
       <p:sp>
         <p:nvSpPr>
-          <p:cNvPr id="32" name="Rounded Rectangle 31"/>
+          <p:cNvPr id="34" name="Rounded Rectangle 33"/>
           <p:cNvSpPr/>
           <p:nvPr/>
         </p:nvSpPr>
@@ -17183,7 +17562,7 @@
       </p:sp>
       <p:sp>
         <p:nvSpPr>
-          <p:cNvPr id="33" name="TextBox 32"/>
+          <p:cNvPr id="35" name="TextBox 34"/>
           <p:cNvSpPr txBox="1"/>
           <p:nvPr/>
         </p:nvSpPr>
@@ -17218,7 +17597,7 @@
       </p:sp>
       <p:sp>
         <p:nvSpPr>
-          <p:cNvPr id="34" name="TextBox 33"/>
+          <p:cNvPr id="36" name="TextBox 35"/>
           <p:cNvSpPr txBox="1"/>
           <p:nvPr/>
         </p:nvSpPr>
@@ -17253,7 +17632,7 @@
       </p:sp>
       <p:sp>
         <p:nvSpPr>
-          <p:cNvPr id="35" name="Rounded Rectangle 34"/>
+          <p:cNvPr id="37" name="Rounded Rectangle 36"/>
           <p:cNvSpPr/>
           <p:nvPr/>
         </p:nvSpPr>
@@ -17298,7 +17677,7 @@
       </p:sp>
       <p:sp>
         <p:nvSpPr>
-          <p:cNvPr id="36" name="TextBox 35"/>
+          <p:cNvPr id="38" name="TextBox 37"/>
           <p:cNvSpPr txBox="1"/>
           <p:nvPr/>
         </p:nvSpPr>
@@ -17326,14 +17705,14 @@
               </a:defRPr>
             </a:pPr>
             <a:r>
-              <a:t>50个</a:t>
-            </a:r>
-          </a:p>
-        </p:txBody>
-      </p:sp>
-      <p:sp>
-        <p:nvSpPr>
-          <p:cNvPr id="37" name="TextBox 36"/>
+              <a:t>任意</a:t>
+            </a:r>
+          </a:p>
+        </p:txBody>
+      </p:sp>
+      <p:sp>
+        <p:nvSpPr>
+          <p:cNvPr id="39" name="TextBox 38"/>
           <p:cNvSpPr txBox="1"/>
           <p:nvPr/>
         </p:nvSpPr>
@@ -17361,7 +17740,7 @@
               </a:defRPr>
             </a:pPr>
             <a:r>
-              <a:t>客户</a:t>
+              <a:t>上传自定义</a:t>
             </a:r>
           </a:p>
         </p:txBody>
@@ -21793,7 +22172,7 @@
               </a:defRPr>
             </a:pPr>
             <a:r>
-              <a:t>从简单查询到复杂多维分析 AI 一键搞定</a:t>
+              <a:t>从简单查询到复杂多维分析 + 自定义数据即插即用</a:t>
             </a:r>
           </a:p>
         </p:txBody>
@@ -22538,7 +22917,7 @@
               </a:defRPr>
             </a:pPr>
             <a:r>
-              <a:t>综合经营</a:t>
+              <a:t>自定义数据</a:t>
             </a:r>
           </a:p>
         </p:txBody>
@@ -22576,7 +22955,7 @@
               </a:defRPr>
             </a:pPr>
             <a:r>
-              <a:t>本月经营简报</a:t>
+              <a:t>上传CSV/Excel即用</a:t>
             </a:r>
           </a:p>
           <a:p>
@@ -22591,7 +22970,7 @@
               </a:defRPr>
             </a:pPr>
             <a:r>
-              <a:t>利润下降原因分析</a:t>
+              <a:t>自动建表+智能问数</a:t>
             </a:r>
           </a:p>
         </p:txBody>

</xml_diff>

<commit_message>
docs: simplify PPT - less formulas, more plain language descriptions
</commit_message>
<xml_diff>
--- a/docs/NL2SQL_答辩PPT.pptx
+++ b/docs/NL2SQL_答辩PPT.pptx
@@ -9743,7 +9743,7 @@
               </a:defRPr>
             </a:pPr>
             <a:r>
-              <a:t>ROI 测算(保守估计)</a:t>
+              <a:t>投入产出测算（保守估计）</a:t>
             </a:r>
           </a:p>
         </p:txBody>
@@ -9781,7 +9781,7 @@
               </a:defRPr>
             </a:pPr>
             <a:r>
-              <a:t>假设:10人管理层每人每月问数5次</a:t>
+              <a:t>假设一个10人管理团队，平均每人每月需要查5次数</a:t>
             </a:r>
           </a:p>
           <a:p>
@@ -9808,7 +9808,7 @@
               </a:defRPr>
             </a:pPr>
             <a:r>
-              <a:t>传统成本:10人x5次/月x2h/次x200元/h = 20,000元/月 -&gt; 240,000元/年</a:t>
+              <a:t>原来的方式: 每次查数平均花2小时等人沟通、写SQL、出报表，人力成本约20,000元/月，一年24万</a:t>
             </a:r>
           </a:p>
           <a:p>
@@ -9823,7 +9823,7 @@
               </a:defRPr>
             </a:pPr>
             <a:r>
-              <a:t>AI方案成本: LLM API 500元/月 + 运维2,000元/月 = 2,500元/月 -&gt; 30,000元/年</a:t>
+              <a:t>用AI的方式: 自己打字提问3秒出结果，大模型API每月约500元，加上运维约2,500元/月，一年仅3万</a:t>
             </a:r>
           </a:p>
           <a:p>
@@ -9850,22 +9850,7 @@
               </a:defRPr>
             </a:pPr>
             <a:r>
-              <a:t>年度净节省: 240,000-30,000 = 210,000元    投资回报率(ROI): 700%</a:t>
-            </a:r>
-          </a:p>
-          <a:p>
-            <a:pPr>
-              <a:spcAft>
-                <a:spcPts val="400"/>
-              </a:spcAft>
-              <a:defRPr sz="1100">
-                <a:solidFill>
-                  <a:srgbClr val="334055"/>
-                </a:solidFill>
-              </a:defRPr>
-            </a:pPr>
-            <a:r>
-              <a:t>以上不含更快决策带来的间接业务价值</a:t>
+              <a:t>一年下来省了21万元，投1块省7块，还不算决策更快带来的隐形收益</a:t>
             </a:r>
           </a:p>
         </p:txBody>
@@ -17914,7 +17899,7 @@
               </a:defRPr>
             </a:pPr>
             <a:r>
-              <a:t>数据模型设计 &amp; 核心财务指标</a:t>
+              <a:t>数据如何组织？—— 数据库设计</a:t>
             </a:r>
           </a:p>
         </p:txBody>
@@ -17992,7 +17977,7 @@
               </a:defRPr>
             </a:pPr>
             <a:r>
-              <a:t>星型模式: 6维度+5事实 | 毛利率/同比/预算执行率</a:t>
+              <a:t>围绕企业经营的 6 个维度 + 5 类业务数据</a:t>
             </a:r>
           </a:p>
         </p:txBody>
@@ -18051,7 +18036,7 @@
         <p:spPr>
           <a:xfrm>
             <a:off x="822960" y="1591056"/>
-            <a:ext cx="1828800" cy="292608"/>
+            <a:ext cx="1645920" cy="292608"/>
           </a:xfrm>
           <a:prstGeom prst="rect">
             <a:avLst/>
@@ -18072,7 +18057,7 @@
               </a:defRPr>
             </a:pPr>
             <a:r>
-              <a:t>dim_date</a:t>
+              <a:t>时间维度</a:t>
             </a:r>
           </a:p>
         </p:txBody>
@@ -18085,8 +18070,8 @@
         </p:nvSpPr>
         <p:spPr>
           <a:xfrm>
-            <a:off x="2743200" y="1591056"/>
-            <a:ext cx="2743200" cy="292608"/>
+            <a:off x="2560320" y="1591056"/>
+            <a:ext cx="3200400" cy="292608"/>
           </a:xfrm>
           <a:prstGeom prst="rect">
             <a:avLst/>
@@ -18107,7 +18092,7 @@
               </a:defRPr>
             </a:pPr>
             <a:r>
-              <a:t>日期维度 / 年/季/月/日</a:t>
+              <a:t>按年/季/月/日分析 / 覆盖2022-2024三年数据</a:t>
             </a:r>
           </a:p>
         </p:txBody>
@@ -18166,7 +18151,7 @@
         <p:spPr>
           <a:xfrm>
             <a:off x="822960" y="2029967"/>
-            <a:ext cx="1828800" cy="292608"/>
+            <a:ext cx="1645920" cy="292608"/>
           </a:xfrm>
           <a:prstGeom prst="rect">
             <a:avLst/>
@@ -18187,7 +18172,7 @@
               </a:defRPr>
             </a:pPr>
             <a:r>
-              <a:t>dim_product</a:t>
+              <a:t>产品维度</a:t>
             </a:r>
           </a:p>
         </p:txBody>
@@ -18200,8 +18185,8 @@
         </p:nvSpPr>
         <p:spPr>
           <a:xfrm>
-            <a:off x="2743200" y="2029967"/>
-            <a:ext cx="2743200" cy="292608"/>
+            <a:off x="2560320" y="2029967"/>
+            <a:ext cx="3200400" cy="292608"/>
           </a:xfrm>
           <a:prstGeom prst="rect">
             <a:avLst/>
@@ -18222,7 +18207,7 @@
               </a:defRPr>
             </a:pPr>
             <a:r>
-              <a:t>产品维度 / 12产品线</a:t>
+              <a:t>12条产品线 / 硬件、软件、服务三大类</a:t>
             </a:r>
           </a:p>
         </p:txBody>
@@ -18281,7 +18266,7 @@
         <p:spPr>
           <a:xfrm>
             <a:off x="822960" y="2468880"/>
-            <a:ext cx="1828800" cy="292608"/>
+            <a:ext cx="1645920" cy="292608"/>
           </a:xfrm>
           <a:prstGeom prst="rect">
             <a:avLst/>
@@ -18302,7 +18287,7 @@
               </a:defRPr>
             </a:pPr>
             <a:r>
-              <a:t>dim_department</a:t>
+              <a:t>部门维度</a:t>
             </a:r>
           </a:p>
         </p:txBody>
@@ -18315,8 +18300,8 @@
         </p:nvSpPr>
         <p:spPr>
           <a:xfrm>
-            <a:off x="2743200" y="2468880"/>
-            <a:ext cx="2743200" cy="292608"/>
+            <a:off x="2560320" y="2468880"/>
+            <a:ext cx="3200400" cy="292608"/>
           </a:xfrm>
           <a:prstGeom prst="rect">
             <a:avLst/>
@@ -18337,7 +18322,7 @@
               </a:defRPr>
             </a:pPr>
             <a:r>
-              <a:t>部门维度 / 8部门</a:t>
+              <a:t>8个部门 / 研发、销售、市场、财务等</a:t>
             </a:r>
           </a:p>
         </p:txBody>
@@ -18396,7 +18381,7 @@
         <p:spPr>
           <a:xfrm>
             <a:off x="822960" y="2907791"/>
-            <a:ext cx="1828800" cy="292608"/>
+            <a:ext cx="1645920" cy="292608"/>
           </a:xfrm>
           <a:prstGeom prst="rect">
             <a:avLst/>
@@ -18417,7 +18402,7 @@
               </a:defRPr>
             </a:pPr>
             <a:r>
-              <a:t>dim_region</a:t>
+              <a:t>区域维度</a:t>
             </a:r>
           </a:p>
         </p:txBody>
@@ -18430,8 +18415,8 @@
         </p:nvSpPr>
         <p:spPr>
           <a:xfrm>
-            <a:off x="2743200" y="2907791"/>
-            <a:ext cx="2743200" cy="292608"/>
+            <a:off x="2560320" y="2907791"/>
+            <a:ext cx="3200400" cy="292608"/>
           </a:xfrm>
           <a:prstGeom prst="rect">
             <a:avLst/>
@@ -18452,7 +18437,7 @@
               </a:defRPr>
             </a:pPr>
             <a:r>
-              <a:t>区域维度 / 6城市4大区</a:t>
+              <a:t>全国6城市4大区 / 华东、华南、华北、西南</a:t>
             </a:r>
           </a:p>
         </p:txBody>
@@ -18511,7 +18496,7 @@
         <p:spPr>
           <a:xfrm>
             <a:off x="822960" y="3346704"/>
-            <a:ext cx="1828800" cy="292608"/>
+            <a:ext cx="1645920" cy="292608"/>
           </a:xfrm>
           <a:prstGeom prst="rect">
             <a:avLst/>
@@ -18532,7 +18517,7 @@
               </a:defRPr>
             </a:pPr>
             <a:r>
-              <a:t>dim_customer</a:t>
+              <a:t>客户维度</a:t>
             </a:r>
           </a:p>
         </p:txBody>
@@ -18545,8 +18530,8 @@
         </p:nvSpPr>
         <p:spPr>
           <a:xfrm>
-            <a:off x="2743200" y="3346704"/>
-            <a:ext cx="2743200" cy="292608"/>
+            <a:off x="2560320" y="3346704"/>
+            <a:ext cx="3200400" cy="292608"/>
           </a:xfrm>
           <a:prstGeom prst="rect">
             <a:avLst/>
@@ -18567,7 +18552,7 @@
               </a:defRPr>
             </a:pPr>
             <a:r>
-              <a:t>客户维度 / 50客户含信用评分</a:t>
+              <a:t>50个客户 / 含信用评级和行业标签</a:t>
             </a:r>
           </a:p>
         </p:txBody>
@@ -18626,7 +18611,7 @@
         <p:spPr>
           <a:xfrm>
             <a:off x="822960" y="3785615"/>
-            <a:ext cx="1828800" cy="292608"/>
+            <a:ext cx="1645920" cy="292608"/>
           </a:xfrm>
           <a:prstGeom prst="rect">
             <a:avLst/>
@@ -18647,7 +18632,7 @@
               </a:defRPr>
             </a:pPr>
             <a:r>
-              <a:t>dim_supplier</a:t>
+              <a:t>供应商</a:t>
             </a:r>
           </a:p>
         </p:txBody>
@@ -18660,8 +18645,8 @@
         </p:nvSpPr>
         <p:spPr>
           <a:xfrm>
-            <a:off x="2743200" y="3785615"/>
-            <a:ext cx="2743200" cy="292608"/>
+            <a:off x="2560320" y="3785615"/>
+            <a:ext cx="3200400" cy="292608"/>
           </a:xfrm>
           <a:prstGeom prst="rect">
             <a:avLst/>
@@ -18682,7 +18667,7 @@
               </a:defRPr>
             </a:pPr>
             <a:r>
-              <a:t>供应商 / 20供应商</a:t>
+              <a:t>20家供应商 / 覆盖主要采购渠道</a:t>
             </a:r>
           </a:p>
         </p:txBody>
@@ -18762,7 +18747,7 @@
               </a:defRPr>
             </a:pPr>
             <a:r>
-              <a:t>fact_sales</a:t>
+              <a:t>销售记录</a:t>
             </a:r>
           </a:p>
         </p:txBody>
@@ -18797,7 +18782,7 @@
               </a:defRPr>
             </a:pPr>
             <a:r>
-              <a:t>20,736行</a:t>
+              <a:t>20,736条</a:t>
             </a:r>
           </a:p>
         </p:txBody>
@@ -18832,7 +18817,7 @@
               </a:defRPr>
             </a:pPr>
             <a:r>
-              <a:t>销售:收入+数量</a:t>
+              <a:t>收入+销量:每笔销售的时间/产品/区域</a:t>
             </a:r>
           </a:p>
         </p:txBody>
@@ -18912,7 +18897,7 @@
               </a:defRPr>
             </a:pPr>
             <a:r>
-              <a:t>fact_cost</a:t>
+              <a:t>成本记录</a:t>
             </a:r>
           </a:p>
         </p:txBody>
@@ -18947,7 +18932,7 @@
               </a:defRPr>
             </a:pPr>
             <a:r>
-              <a:t>18,412行</a:t>
+              <a:t>18,412条</a:t>
             </a:r>
           </a:p>
         </p:txBody>
@@ -18982,7 +18967,7 @@
               </a:defRPr>
             </a:pPr>
             <a:r>
-              <a:t>成本:直接/间接</a:t>
+              <a:t>直接+间接成本:与销售收入精细匹配</a:t>
             </a:r>
           </a:p>
         </p:txBody>
@@ -19062,7 +19047,7 @@
               </a:defRPr>
             </a:pPr>
             <a:r>
-              <a:t>fact_expense</a:t>
+              <a:t>费用记录</a:t>
             </a:r>
           </a:p>
         </p:txBody>
@@ -19097,7 +19082,7 @@
               </a:defRPr>
             </a:pPr>
             <a:r>
-              <a:t>17,280行</a:t>
+              <a:t>17,280条</a:t>
             </a:r>
           </a:p>
         </p:txBody>
@@ -19132,7 +19117,7 @@
               </a:defRPr>
             </a:pPr>
             <a:r>
-              <a:t>费用:预算vs实际</a:t>
+              <a:t>预算+实际:各部门预算执行情况追踪</a:t>
             </a:r>
           </a:p>
         </p:txBody>
@@ -19212,7 +19197,7 @@
               </a:defRPr>
             </a:pPr>
             <a:r>
-              <a:t>fact_receivable</a:t>
+              <a:t>应收记录</a:t>
             </a:r>
           </a:p>
         </p:txBody>
@@ -19247,7 +19232,7 @@
               </a:defRPr>
             </a:pPr>
             <a:r>
-              <a:t>1,644行</a:t>
+              <a:t>1,644条</a:t>
             </a:r>
           </a:p>
         </p:txBody>
@@ -19282,7 +19267,7 @@
               </a:defRPr>
             </a:pPr>
             <a:r>
-              <a:t>应收:逾期标记</a:t>
+              <a:t>客户欠款:含是否逾期和逾期天数</a:t>
             </a:r>
           </a:p>
         </p:txBody>
@@ -19362,7 +19347,7 @@
               </a:defRPr>
             </a:pPr>
             <a:r>
-              <a:t>fact_payable</a:t>
+              <a:t>应付记录</a:t>
             </a:r>
           </a:p>
         </p:txBody>
@@ -19397,7 +19382,7 @@
               </a:defRPr>
             </a:pPr>
             <a:r>
-              <a:t>446行</a:t>
+              <a:t>446条</a:t>
             </a:r>
           </a:p>
         </p:txBody>
@@ -19432,7 +19417,7 @@
               </a:defRPr>
             </a:pPr>
             <a:r>
-              <a:t>应付:到期日</a:t>
+              <a:t>公司欠款:供应商付款到期日管理</a:t>
             </a:r>
           </a:p>
         </p:txBody>
@@ -19467,7 +19452,7 @@
               </a:defRPr>
             </a:pPr>
             <a:r>
-              <a:t>核心财务指标计算公式</a:t>
+              <a:t>系统能回答哪些财务问题？</a:t>
             </a:r>
           </a:p>
         </p:txBody>
@@ -19496,7 +19481,7 @@
           <a:p>
             <a:pPr>
               <a:spcAft>
-                <a:spcPts val="600"/>
+                <a:spcPts val="500"/>
               </a:spcAft>
               <a:defRPr sz="1000">
                 <a:solidFill>
@@ -19505,13 +19490,13 @@
               </a:defRPr>
             </a:pPr>
             <a:r>
-              <a:t>毛利率=(收入-成本)/收入*100%      净利率=(收入-成本-费用)/收入*100%</a:t>
+              <a:t>营收: 某个区域、产品线、时间段赚了多少钱？跟去年同期比涨了还是跌了？</a:t>
             </a:r>
           </a:p>
           <a:p>
             <a:pPr>
               <a:spcAft>
-                <a:spcPts val="600"/>
+                <a:spcPts val="500"/>
               </a:spcAft>
               <a:defRPr sz="1000">
                 <a:solidFill>
@@ -19520,13 +19505,13 @@
               </a:defRPr>
             </a:pPr>
             <a:r>
-              <a:t>同比=(本期-去年同期)/去年同期*100%      预算执行率=实际/预算*100%</a:t>
+              <a:t>盈利: 哪个产品最赚钱？哪个区域的毛利率在下降？需要重点关注什么地方？</a:t>
             </a:r>
           </a:p>
           <a:p>
             <a:pPr>
               <a:spcAft>
-                <a:spcPts val="600"/>
+                <a:spcPts val="500"/>
               </a:spcAft>
               <a:defRPr sz="1000">
                 <a:solidFill>
@@ -19535,7 +19520,37 @@
               </a:defRPr>
             </a:pPr>
             <a:r>
-              <a:t>费用率=费用/收入*100%      回款率=已收/应收*100%      周转天数=平均应收/日均收入*365</a:t>
+              <a:t>花钱: 各部门花了多少钱？有没有超预算？哪类费用增长最快？</a:t>
+            </a:r>
+          </a:p>
+          <a:p>
+            <a:pPr>
+              <a:spcAft>
+                <a:spcPts val="500"/>
+              </a:spcAft>
+              <a:defRPr sz="1000">
+                <a:solidFill>
+                  <a:srgbClr val="334055"/>
+                </a:solidFill>
+              </a:defRPr>
+            </a:pPr>
+            <a:r>
+              <a:t>回款: 哪些客户欠款还没还？欠了多少？超过约定期限多久了？该催谁？</a:t>
+            </a:r>
+          </a:p>
+          <a:p>
+            <a:pPr>
+              <a:spcAft>
+                <a:spcPts val="500"/>
+              </a:spcAft>
+              <a:defRPr sz="1000">
+                <a:solidFill>
+                  <a:srgbClr val="334055"/>
+                </a:solidFill>
+              </a:defRPr>
+            </a:pPr>
+            <a:r>
+              <a:t>综合: 上个月公司整体经营情况怎么样？收入、利润、费用、回款都正常吗？</a:t>
             </a:r>
           </a:p>
         </p:txBody>
@@ -19709,7 +19724,7 @@
               </a:defRPr>
             </a:pPr>
             <a:r>
-              <a:t>NL2SQL核心技术 - 五层 Prompt 注入策略</a:t>
+              <a:t>AI 怎样准确理解财务问题？</a:t>
             </a:r>
           </a:p>
         </p:txBody>
@@ -19787,7 +19802,7 @@
               </a:defRPr>
             </a:pPr>
             <a:r>
-              <a:t>分层注入 vs 堆叠: 准确率 72% to 88%</a:t>
+              <a:t>不是简单把问题丢给AI，而是分五层逐步引导，准确率从72%提升到88%</a:t>
             </a:r>
           </a:p>
         </p:txBody>
@@ -19900,7 +19915,7 @@
               </a:defRPr>
             </a:pPr>
             <a:r>
-              <a:t>系统角色</a:t>
+              <a:t>告诉AI它是谁</a:t>
             </a:r>
           </a:p>
         </p:txBody>
@@ -19913,8 +19928,8 @@
         </p:nvSpPr>
         <p:spPr>
           <a:xfrm>
-            <a:off x="1371600" y="1755648"/>
-            <a:ext cx="6400800" cy="274320"/>
+            <a:off x="1371600" y="1737360"/>
+            <a:ext cx="7315200" cy="457200"/>
           </a:xfrm>
           <a:prstGeom prst="rect">
             <a:avLst/>
@@ -19935,7 +19950,11 @@
               </a:defRPr>
             </a:pPr>
             <a:r>
-              <a:t>资深财务数据分析师精通SQL</a:t>
+              <a:t>你是一位资深财务数据分析师</a:t>
+            </a:r>
+            <a:br/>
+            <a:r>
+              <a:t>精通企业经营指标和SQL</a:t>
             </a:r>
           </a:p>
         </p:txBody>
@@ -19948,8 +19967,8 @@
         </p:nvSpPr>
         <p:spPr>
           <a:xfrm>
-            <a:off x="8686800" y="1554480"/>
-            <a:ext cx="3200400" cy="274320"/>
+            <a:off x="8961120" y="1554480"/>
+            <a:ext cx="2743200" cy="274320"/>
           </a:xfrm>
           <a:prstGeom prst="rect">
             <a:avLst/>
@@ -19963,14 +19982,14 @@
           <a:lstStyle/>
           <a:p>
             <a:pPr algn="l">
-              <a:defRPr sz="1000" b="0">
+              <a:defRPr sz="900" b="0">
                 <a:solidFill>
                   <a:srgbClr val="94A3B8"/>
                 </a:solidFill>
               </a:defRPr>
             </a:pPr>
             <a:r>
-              <a:t>to 约束输出风格</a:t>
+              <a:t>目的: 让AI进入角色</a:t>
             </a:r>
           </a:p>
         </p:txBody>
@@ -20083,7 +20102,7 @@
               </a:defRPr>
             </a:pPr>
             <a:r>
-              <a:t>数据库Schema</a:t>
+              <a:t>告诉AI有哪些数据</a:t>
             </a:r>
           </a:p>
         </p:txBody>
@@ -20096,8 +20115,8 @@
         </p:nvSpPr>
         <p:spPr>
           <a:xfrm>
-            <a:off x="1371600" y="2532888"/>
-            <a:ext cx="6400800" cy="274320"/>
+            <a:off x="1371600" y="2514600"/>
+            <a:ext cx="7315200" cy="457200"/>
           </a:xfrm>
           <a:prstGeom prst="rect">
             <a:avLst/>
@@ -20118,7 +20137,11 @@
               </a:defRPr>
             </a:pPr>
             <a:r>
-              <a:t>12张表完整结构字段含义</a:t>
+              <a:t>数据库有12张表，每张表存什么信息</a:t>
+            </a:r>
+            <a:br/>
+            <a:r>
+              <a:t>字段名称和含义是什么</a:t>
             </a:r>
           </a:p>
         </p:txBody>
@@ -20131,8 +20154,8 @@
         </p:nvSpPr>
         <p:spPr>
           <a:xfrm>
-            <a:off x="8686800" y="2331720"/>
-            <a:ext cx="3200400" cy="274320"/>
+            <a:off x="8961120" y="2331720"/>
+            <a:ext cx="2743200" cy="274320"/>
           </a:xfrm>
           <a:prstGeom prst="rect">
             <a:avLst/>
@@ -20146,14 +20169,14 @@
           <a:lstStyle/>
           <a:p>
             <a:pPr algn="l">
-              <a:defRPr sz="1000" b="0">
+              <a:defRPr sz="900" b="0">
                 <a:solidFill>
                   <a:srgbClr val="94A3B8"/>
                 </a:solidFill>
               </a:defRPr>
             </a:pPr>
             <a:r>
-              <a:t>to 防幻觉字段</a:t>
+              <a:t>目的: 防止AI瞎编字段</a:t>
             </a:r>
           </a:p>
         </p:txBody>
@@ -20266,7 +20289,7 @@
               </a:defRPr>
             </a:pPr>
             <a:r>
-              <a:t>业务规则</a:t>
+              <a:t>告诉AI怎么算</a:t>
             </a:r>
           </a:p>
         </p:txBody>
@@ -20279,8 +20302,8 @@
         </p:nvSpPr>
         <p:spPr>
           <a:xfrm>
-            <a:off x="1371600" y="3310127"/>
-            <a:ext cx="6400800" cy="274320"/>
+            <a:off x="1371600" y="3291839"/>
+            <a:ext cx="7315200" cy="457200"/>
           </a:xfrm>
           <a:prstGeom prst="rect">
             <a:avLst/>
@@ -20301,7 +20324,11 @@
               </a:defRPr>
             </a:pPr>
             <a:r>
-              <a:t>毛利率/同比公式区域映射</a:t>
+              <a:t>毛利率是(收入-成本)/收入</a:t>
+            </a:r>
+            <a:br/>
+            <a:r>
+              <a:t>同比是和去年同期比较</a:t>
             </a:r>
           </a:p>
         </p:txBody>
@@ -20314,8 +20341,8 @@
         </p:nvSpPr>
         <p:spPr>
           <a:xfrm>
-            <a:off x="8686800" y="3108960"/>
-            <a:ext cx="3200400" cy="274320"/>
+            <a:off x="8961120" y="3108960"/>
+            <a:ext cx="2743200" cy="274320"/>
           </a:xfrm>
           <a:prstGeom prst="rect">
             <a:avLst/>
@@ -20329,14 +20356,14 @@
           <a:lstStyle/>
           <a:p>
             <a:pPr algn="l">
-              <a:defRPr sz="1000" b="0">
+              <a:defRPr sz="900" b="0">
                 <a:solidFill>
                   <a:srgbClr val="94A3B8"/>
                 </a:solidFill>
               </a:defRPr>
             </a:pPr>
             <a:r>
-              <a:t>to 确保计算正确</a:t>
+              <a:t>目的: 确保计算逻辑正确</a:t>
             </a:r>
           </a:p>
         </p:txBody>
@@ -20449,7 +20476,7 @@
               </a:defRPr>
             </a:pPr>
             <a:r>
-              <a:t>Few-shot示例</a:t>
+              <a:t>给AI看几个例子</a:t>
             </a:r>
           </a:p>
         </p:txBody>
@@ -20462,8 +20489,8 @@
         </p:nvSpPr>
         <p:spPr>
           <a:xfrm>
-            <a:off x="1371600" y="4087368"/>
-            <a:ext cx="6400800" cy="274320"/>
+            <a:off x="1371600" y="4069080"/>
+            <a:ext cx="7315200" cy="457200"/>
           </a:xfrm>
           <a:prstGeom prst="rect">
             <a:avLst/>
@@ -20484,7 +20511,11 @@
               </a:defRPr>
             </a:pPr>
             <a:r>
-              <a:t>3-5个自然语言toSQL配对</a:t>
+              <a:t>类似问题应该生成什么样的SQL</a:t>
+            </a:r>
+            <a:br/>
+            <a:r>
+              <a:t>给3-5个标准问答示范</a:t>
             </a:r>
           </a:p>
         </p:txBody>
@@ -20497,8 +20528,8 @@
         </p:nvSpPr>
         <p:spPr>
           <a:xfrm>
-            <a:off x="8686800" y="3886200"/>
-            <a:ext cx="3200400" cy="274320"/>
+            <a:off x="8961120" y="3886200"/>
+            <a:ext cx="2743200" cy="274320"/>
           </a:xfrm>
           <a:prstGeom prst="rect">
             <a:avLst/>
@@ -20512,14 +20543,14 @@
           <a:lstStyle/>
           <a:p>
             <a:pPr algn="l">
-              <a:defRPr sz="1000" b="0">
+              <a:defRPr sz="900" b="0">
                 <a:solidFill>
                   <a:srgbClr val="94A3B8"/>
                 </a:solidFill>
               </a:defRPr>
             </a:pPr>
             <a:r>
-              <a:t>to 引导生成模式</a:t>
+              <a:t>目的: 让AI模仿正确格式</a:t>
             </a:r>
           </a:p>
         </p:txBody>
@@ -20632,7 +20663,7 @@
               </a:defRPr>
             </a:pPr>
             <a:r>
-              <a:t>用户问题</a:t>
+              <a:t>提出用户真正的问题</a:t>
             </a:r>
           </a:p>
         </p:txBody>
@@ -20645,8 +20676,8 @@
         </p:nvSpPr>
         <p:spPr>
           <a:xfrm>
-            <a:off x="1371600" y="4864608"/>
-            <a:ext cx="6400800" cy="274320"/>
+            <a:off x="1371600" y="4846320"/>
+            <a:ext cx="7315200" cy="457200"/>
           </a:xfrm>
           <a:prstGeom prst="rect">
             <a:avLst/>
@@ -20667,7 +20698,11 @@
               </a:defRPr>
             </a:pPr>
             <a:r>
-              <a:t>华东区Q2毛利率同比变化</a:t>
+              <a:t>华东区第二季度毛利率</a:t>
+            </a:r>
+            <a:br/>
+            <a:r>
+              <a:t>和去年同期相比变化多少？</a:t>
             </a:r>
           </a:p>
         </p:txBody>
@@ -20680,8 +20715,8 @@
         </p:nvSpPr>
         <p:spPr>
           <a:xfrm>
-            <a:off x="8686800" y="4663440"/>
-            <a:ext cx="3200400" cy="274320"/>
+            <a:off x="8961120" y="4663440"/>
+            <a:ext cx="2743200" cy="274320"/>
           </a:xfrm>
           <a:prstGeom prst="rect">
             <a:avLst/>
@@ -20695,14 +20730,14 @@
           <a:lstStyle/>
           <a:p>
             <a:pPr algn="l">
-              <a:defRPr sz="1000" b="0">
+              <a:defRPr sz="900" b="0">
                 <a:solidFill>
                   <a:srgbClr val="94A3B8"/>
                 </a:solidFill>
               </a:defRPr>
             </a:pPr>
             <a:r>
-              <a:t>to 最终回答目标</a:t>
+              <a:t>目的: 结合前面知识给出答案</a:t>
             </a:r>
           </a:p>
         </p:txBody>
@@ -20783,7 +20818,7 @@
               </a:defRPr>
             </a:pPr>
             <a:r>
-              <a:t>实验结果: 不分层72% | 五层分层88% | 分层+7示例91% =&gt; 分层比堆叠准确率提升约15个百分点</a:t>
+              <a:t>效果验证: 直接让AI生成SQL准确率仅72% | 五层逐步引导后达到88% | 再加更多示例可达91%</a:t>
             </a:r>
           </a:p>
         </p:txBody>
@@ -20957,7 +20992,7 @@
               </a:defRPr>
             </a:pPr>
             <a:r>
-              <a:t>SQL 安全校验与自动纠错</a:t>
+              <a:t>如何保证AI生成的SQL安全可靠？</a:t>
             </a:r>
           </a:p>
         </p:txBody>
@@ -21035,7 +21070,7 @@
               </a:defRPr>
             </a:pPr>
             <a:r>
-              <a:t>4道防线 + 最多3次自动重试 纠错成功率80%+</a:t>
+              <a:t>AI可能犯错，我们设了4道防线 + 最多3次自动修正</a:t>
             </a:r>
           </a:p>
         </p:txBody>
@@ -21108,14 +21143,18 @@
           <a:lstStyle/>
           <a:p>
             <a:pPr algn="ctr">
-              <a:defRPr sz="1300" b="1">
+              <a:defRPr sz="1200" b="1">
                 <a:solidFill>
                   <a:srgbClr val="0D2B5E"/>
                 </a:solidFill>
               </a:defRPr>
             </a:pPr>
             <a:r>
-              <a:t>语法校验</a:t>
+              <a:t>语法检查</a:t>
+            </a:r>
+            <a:br/>
+            <a:r>
+              <a:t>SQL写法对不对</a:t>
             </a:r>
           </a:p>
         </p:txBody>
@@ -21223,7 +21262,7 @@
           <a:lstStyle/>
           <a:p>
             <a:pPr algn="ctr">
-              <a:defRPr sz="1300" b="1">
+              <a:defRPr sz="1200" b="1">
                 <a:solidFill>
                   <a:srgbClr val="0D2B5E"/>
                 </a:solidFill>
@@ -21234,7 +21273,7 @@
             </a:r>
             <a:br/>
             <a:r>
-              <a:t>(仅SELECT)</a:t>
+              <a:t>只能查不能改</a:t>
             </a:r>
           </a:p>
         </p:txBody>
@@ -21342,18 +21381,18 @@
           <a:lstStyle/>
           <a:p>
             <a:pPr algn="ctr">
-              <a:defRPr sz="1300" b="1">
+              <a:defRPr sz="1200" b="1">
                 <a:solidFill>
                   <a:srgbClr val="0D2B5E"/>
                 </a:solidFill>
               </a:defRPr>
             </a:pPr>
             <a:r>
-              <a:t>表名/字段名</a:t>
+              <a:t>表名检查</a:t>
             </a:r>
             <a:br/>
             <a:r>
-              <a:t>校验</a:t>
+              <a:t>数据表存在吗</a:t>
             </a:r>
           </a:p>
         </p:txBody>
@@ -21461,7 +21500,7 @@
           <a:lstStyle/>
           <a:p>
             <a:pPr algn="ctr">
-              <a:defRPr sz="1300" b="1">
+              <a:defRPr sz="1200" b="1">
                 <a:solidFill>
                   <a:srgbClr val="0D2B5E"/>
                 </a:solidFill>
@@ -21469,6 +21508,10 @@
             </a:pPr>
             <a:r>
               <a:t>执行验证</a:t>
+            </a:r>
+            <a:br/>
+            <a:r>
+              <a:t>跑一遍看结果</a:t>
             </a:r>
           </a:p>
         </p:txBody>
@@ -21546,7 +21589,7 @@
               </a:defRPr>
             </a:pPr>
             <a:r>
-              <a:t>拦截危险操作</a:t>
+              <a:t>防删库跑路</a:t>
             </a:r>
           </a:p>
         </p:txBody>
@@ -21581,7 +21624,7 @@
               </a:defRPr>
             </a:pPr>
             <a:r>
-              <a:t>DROP/DELETE/UPDATE/INSERT等DML/DDL全部拦截</a:t>
+              <a:t>系统只允许查询操作，删除、修改、建表等危险命令全部拦截</a:t>
             </a:r>
           </a:p>
         </p:txBody>
@@ -21659,7 +21702,7 @@
               </a:defRPr>
             </a:pPr>
             <a:r>
-              <a:t>防幻觉字段</a:t>
+              <a:t>防胡说八道</a:t>
             </a:r>
           </a:p>
         </p:txBody>
@@ -21694,7 +21737,7 @@
               </a:defRPr>
             </a:pPr>
             <a:r>
-              <a:t>表名/字段名白名单校验不存在的字段自动标记</a:t>
+              <a:t>AI可能编造不存在的表名和字段，白名单机制确保只查真实数据</a:t>
             </a:r>
           </a:p>
         </p:txBody>
@@ -21772,7 +21815,7 @@
               </a:defRPr>
             </a:pPr>
             <a:r>
-              <a:t>自动纠错</a:t>
+              <a:t>自动修正</a:t>
             </a:r>
           </a:p>
         </p:txBody>
@@ -21807,7 +21850,7 @@
               </a:defRPr>
             </a:pPr>
             <a:r>
-              <a:t>校验失败to错误反馈LLMto重新生成to最多3次</a:t>
+              <a:t>生成出错不要紧，系统会把错误反馈给AI让它重新生成，最多试3次</a:t>
             </a:r>
           </a:p>
         </p:txBody>
@@ -21885,7 +21928,7 @@
               </a:defRPr>
             </a:pPr>
             <a:r>
-              <a:t>纠错成功率</a:t>
+              <a:t>实战效果</a:t>
             </a:r>
           </a:p>
         </p:txBody>
@@ -21920,7 +21963,7 @@
               </a:defRPr>
             </a:pPr>
             <a:r>
-              <a:t>80%+的错误在3次重试内被自动修复</a:t>
+              <a:t>超过80%的错误能在3次重试内自动修复，用户无感知</a:t>
             </a:r>
           </a:p>
         </p:txBody>

</xml_diff>

<commit_message>
docs: balance PPT tone - professional but clear
</commit_message>
<xml_diff>
--- a/docs/NL2SQL_答辩PPT.pptx
+++ b/docs/NL2SQL_答辩PPT.pptx
@@ -9781,7 +9781,7 @@
               </a:defRPr>
             </a:pPr>
             <a:r>
-              <a:t>假设一个10人管理团队，平均每人每月需要查5次数</a:t>
+              <a:t>测算前提: 10人管理团队，每人每月平均查询5次经营数据</a:t>
             </a:r>
           </a:p>
           <a:p>
@@ -9808,7 +9808,7 @@
               </a:defRPr>
             </a:pPr>
             <a:r>
-              <a:t>原来的方式: 每次查数平均花2小时等人沟通、写SQL、出报表，人力成本约20,000元/月，一年24万</a:t>
+              <a:t>传统模式成本: 每次查询平均耗时2小时（沟通+写SQL+出报表）× 人力成本200元/小时 ≈ 20,000元/月 → 240,000元/年</a:t>
             </a:r>
           </a:p>
           <a:p>
@@ -9823,7 +9823,7 @@
               </a:defRPr>
             </a:pPr>
             <a:r>
-              <a:t>用AI的方式: 自己打字提问3秒出结果，大模型API每月约500元，加上运维约2,500元/月，一年仅3万</a:t>
+              <a:t>AI方案成本: 大模型API调用约500元/月 + 系统运维约2,000元/月 ≈ 2,500元/月 → 30,000元/年</a:t>
             </a:r>
           </a:p>
           <a:p>
@@ -9850,7 +9850,22 @@
               </a:defRPr>
             </a:pPr>
             <a:r>
-              <a:t>一年下来省了21万元，投1块省7块，还不算决策更快带来的隐形收益</a:t>
+              <a:t>年度净节省: 240,000 - 30,000 = 210,000元    投资回报率(ROI): 700%</a:t>
+            </a:r>
+          </a:p>
+          <a:p>
+            <a:pPr>
+              <a:spcAft>
+                <a:spcPts val="400"/>
+              </a:spcAft>
+              <a:defRPr sz="1100">
+                <a:solidFill>
+                  <a:srgbClr val="334055"/>
+                </a:solidFill>
+              </a:defRPr>
+            </a:pPr>
+            <a:r>
+              <a:t>注: 以上仅为可量化的人力成本，不含决策提速带来的间接业务价值</a:t>
             </a:r>
           </a:p>
         </p:txBody>
@@ -21589,7 +21604,7 @@
               </a:defRPr>
             </a:pPr>
             <a:r>
-              <a:t>防删库跑路</a:t>
+              <a:t>操作权限控制</a:t>
             </a:r>
           </a:p>
         </p:txBody>
@@ -21624,7 +21639,7 @@
               </a:defRPr>
             </a:pPr>
             <a:r>
-              <a:t>系统只允许查询操作，删除、修改、建表等危险命令全部拦截</a:t>
+              <a:t>仅开放SELECT查询权限，拦截DROP/DELETE/UPDATE等危险操作</a:t>
             </a:r>
           </a:p>
         </p:txBody>
@@ -21702,7 +21717,7 @@
               </a:defRPr>
             </a:pPr>
             <a:r>
-              <a:t>防胡说八道</a:t>
+              <a:t>表名字段校验</a:t>
             </a:r>
           </a:p>
         </p:txBody>
@@ -21737,7 +21752,7 @@
               </a:defRPr>
             </a:pPr>
             <a:r>
-              <a:t>AI可能编造不存在的表名和字段，白名单机制确保只查真实数据</a:t>
+              <a:t>白名单机制验证SQL中的表名和字段名，防止AI幻觉产生不存在的对象</a:t>
             </a:r>
           </a:p>
         </p:txBody>
@@ -21815,7 +21830,7 @@
               </a:defRPr>
             </a:pPr>
             <a:r>
-              <a:t>自动修正</a:t>
+              <a:t>自动纠错闭环</a:t>
             </a:r>
           </a:p>
         </p:txBody>
@@ -21850,7 +21865,7 @@
               </a:defRPr>
             </a:pPr>
             <a:r>
-              <a:t>生成出错不要紧，系统会把错误反馈给AI让它重新生成，最多试3次</a:t>
+              <a:t>校验失败时将错误信息反馈给LLM，引导其修正SQL并重新生成，最多重试3次</a:t>
             </a:r>
           </a:p>
         </p:txBody>
@@ -21963,7 +21978,7 @@
               </a:defRPr>
             </a:pPr>
             <a:r>
-              <a:t>超过80%的错误能在3次重试内自动修复，用户无感知</a:t>
+              <a:t>超过80%的错误在3次重试内自动修复，用户无需关心底层纠错过程</a:t>
             </a:r>
           </a:p>
         </p:txBody>

</xml_diff>

<commit_message>
docs: regenerate PPT after closing PowerPoint lock
</commit_message>
<xml_diff>
--- a/docs/NL2SQL_答辩PPT.pptx
+++ b/docs/NL2SQL_答辩PPT.pptx
@@ -8242,7 +8242,7 @@
               </a:defRPr>
             </a:pPr>
             <a:r>
-              <a:t>不只是工具更是能力增强器</a:t>
+              <a:t>不只是工具，而是贯穿整个问数流程的智能引擎</a:t>
             </a:r>
           </a:p>
         </p:txBody>
@@ -8360,7 +8360,7 @@
               </a:defRPr>
             </a:pPr>
             <a:r>
-              <a:t>自然语言 to SQL</a:t>
+              <a:t>将自然语言精准转换为SQL查询</a:t>
             </a:r>
           </a:p>
           <a:p>
@@ -8375,7 +8375,7 @@
               </a:defRPr>
             </a:pPr>
             <a:r>
-              <a:t>理解业务术语时间表述维度映射</a:t>
+              <a:t>理解业务术语如毛利率、同比、预算执行率</a:t>
             </a:r>
           </a:p>
           <a:p>
@@ -8390,7 +8390,22 @@
               </a:defRPr>
             </a:pPr>
             <a:r>
-              <a:t>华东区毛利率 to SELECT JOIN</a:t>
+              <a:t>自动识别时间范围、区域、产品线等维度</a:t>
+            </a:r>
+          </a:p>
+          <a:p>
+            <a:pPr>
+              <a:spcAft>
+                <a:spcPts val="1000"/>
+              </a:spcAft>
+              <a:defRPr sz="1200">
+                <a:solidFill>
+                  <a:srgbClr val="334055"/>
+                </a:solidFill>
+              </a:defRPr>
+            </a:pPr>
+            <a:r>
+              <a:t>华东区毛利率 → SELECT...JOIN...WHERE</a:t>
             </a:r>
           </a:p>
         </p:txBody>
@@ -8508,7 +8523,7 @@
               </a:defRPr>
             </a:pPr>
             <a:r>
-              <a:t>查询结果 to 经营解读</a:t>
+              <a:t>查询结果自动生成经营分析解读</a:t>
             </a:r>
           </a:p>
           <a:p>
@@ -8523,7 +8538,7 @@
               </a:defRPr>
             </a:pPr>
             <a:r>
-              <a:t>发现异常分析原因评估影响</a:t>
+              <a:t>包含: 数据摘要、变动原因分析</a:t>
             </a:r>
           </a:p>
           <a:p>
@@ -8538,7 +8553,22 @@
               </a:defRPr>
             </a:pPr>
             <a:r>
-              <a:t>毛利率下降2.1%主因成本上升</a:t>
+              <a:t>影响因素拆解和风险提示</a:t>
+            </a:r>
+          </a:p>
+          <a:p>
+            <a:pPr>
+              <a:spcAft>
+                <a:spcPts val="1000"/>
+              </a:spcAft>
+              <a:defRPr sz="1200">
+                <a:solidFill>
+                  <a:srgbClr val="334055"/>
+                </a:solidFill>
+              </a:defRPr>
+            </a:pPr>
+            <a:r>
+              <a:t>毛利率下降2.1%主因原材料成本上升8.3%</a:t>
             </a:r>
           </a:p>
         </p:txBody>
@@ -8656,7 +8686,7 @@
               </a:defRPr>
             </a:pPr>
             <a:r>
-              <a:t>自动校验+纠错</a:t>
+              <a:t>四道防线确保生成的SQL安全可执行</a:t>
             </a:r>
           </a:p>
           <a:p>
@@ -8671,7 +8701,7 @@
               </a:defRPr>
             </a:pPr>
             <a:r>
-              <a:t>语法检查权限控制字段验证</a:t>
+              <a:t>语法校验 → 权限检查 → 字段验证 → 执行测试</a:t>
             </a:r>
           </a:p>
           <a:p>
@@ -8686,7 +8716,22 @@
               </a:defRPr>
             </a:pPr>
             <a:r>
-              <a:t>失败自动反馈LLM重试最多3次</a:t>
+              <a:t>校验失败自动反馈LLM修正，最多重试3次</a:t>
+            </a:r>
+          </a:p>
+          <a:p>
+            <a:pPr>
+              <a:spcAft>
+                <a:spcPts val="1000"/>
+              </a:spcAft>
+              <a:defRPr sz="1200">
+                <a:solidFill>
+                  <a:srgbClr val="334055"/>
+                </a:solidFill>
+              </a:defRPr>
+            </a:pPr>
+            <a:r>
+              <a:t>80%+的错误在重试中被自动修复</a:t>
             </a:r>
           </a:p>
         </p:txBody>
@@ -10117,7 +10162,7 @@
               </a:defRPr>
             </a:pPr>
             <a:r>
-              <a:t>超越数字的战略意义</a:t>
+              <a:t>超越数字的战略意义，改变企业数据使用方式</a:t>
             </a:r>
           </a:p>
         </p:txBody>
@@ -10235,7 +10280,7 @@
               </a:defRPr>
             </a:pPr>
             <a:r>
-              <a:t>从会上提问会后查数到当场问当场出结果</a:t>
+              <a:t>从会前准备报表到会中实时问数</a:t>
             </a:r>
           </a:p>
           <a:p>
@@ -10250,7 +10295,37 @@
               </a:defRPr>
             </a:pPr>
             <a:r>
-              <a:t>决策节奏从月/周级to分钟级</a:t>
+              <a:t>管理层可以当场追问、当场验证假设</a:t>
+            </a:r>
+          </a:p>
+          <a:p>
+            <a:pPr>
+              <a:spcAft>
+                <a:spcPts val="600"/>
+              </a:spcAft>
+              <a:defRPr sz="1200">
+                <a:solidFill>
+                  <a:srgbClr val="334055"/>
+                </a:solidFill>
+              </a:defRPr>
+            </a:pPr>
+            <a:r>
+              <a:t>决策节奏从月/周级缩短到分钟级</a:t>
+            </a:r>
+          </a:p>
+          <a:p>
+            <a:pPr>
+              <a:spcAft>
+                <a:spcPts val="600"/>
+              </a:spcAft>
+              <a:defRPr sz="1200">
+                <a:solidFill>
+                  <a:srgbClr val="334055"/>
+                </a:solidFill>
+              </a:defRPr>
+            </a:pPr>
+            <a:r>
+              <a:t>典型场景: 经营分析会中直接问毛利率变化原因</a:t>
             </a:r>
           </a:p>
         </p:txBody>
@@ -10368,7 +10443,7 @@
               </a:defRPr>
             </a:pPr>
             <a:r>
-              <a:t>每个部门经理都能自助问数不再依赖BI团队</a:t>
+              <a:t>每个部门经理都可以用自然语言查数据</a:t>
             </a:r>
           </a:p>
           <a:p>
@@ -10383,7 +10458,37 @@
               </a:defRPr>
             </a:pPr>
             <a:r>
-              <a:t>消除数据垄断释放组织数据活力</a:t>
+              <a:t>不再依赖BI团队排期，消除数据瓶颈</a:t>
+            </a:r>
+          </a:p>
+          <a:p>
+            <a:pPr>
+              <a:spcAft>
+                <a:spcPts val="600"/>
+              </a:spcAft>
+              <a:defRPr sz="1200">
+                <a:solidFill>
+                  <a:srgbClr val="334055"/>
+                </a:solidFill>
+              </a:defRPr>
+            </a:pPr>
+            <a:r>
+              <a:t>让数据从少数人的工具变为全员可用</a:t>
+            </a:r>
+          </a:p>
+          <a:p>
+            <a:pPr>
+              <a:spcAft>
+                <a:spcPts val="600"/>
+              </a:spcAft>
+              <a:defRPr sz="1200">
+                <a:solidFill>
+                  <a:srgbClr val="334055"/>
+                </a:solidFill>
+              </a:defRPr>
+            </a:pPr>
+            <a:r>
+              <a:t>释放组织各级人员的数据分析潜能</a:t>
             </a:r>
           </a:p>
         </p:txBody>
@@ -10501,7 +10606,7 @@
               </a:defRPr>
             </a:pPr>
             <a:r>
-              <a:t>月底出报表to实时AI监控预警</a:t>
+              <a:t>从月底出报表的事后总结变为实时监控</a:t>
             </a:r>
           </a:p>
           <a:p>
@@ -10516,7 +10621,37 @@
               </a:defRPr>
             </a:pPr>
             <a:r>
-              <a:t>风险发现从事后变为事中/事前</a:t>
+              <a:t>AI自动识别异常指标并主动预警</a:t>
+            </a:r>
+          </a:p>
+          <a:p>
+            <a:pPr>
+              <a:spcAft>
+                <a:spcPts val="600"/>
+              </a:spcAft>
+              <a:defRPr sz="1200">
+                <a:solidFill>
+                  <a:srgbClr val="334055"/>
+                </a:solidFill>
+              </a:defRPr>
+            </a:pPr>
+            <a:r>
+              <a:t>逾期应收、预算超支、毛利下滑即时发现</a:t>
+            </a:r>
+          </a:p>
+          <a:p>
+            <a:pPr>
+              <a:spcAft>
+                <a:spcPts val="600"/>
+              </a:spcAft>
+              <a:defRPr sz="1200">
+                <a:solidFill>
+                  <a:srgbClr val="334055"/>
+                </a:solidFill>
+              </a:defRPr>
+            </a:pPr>
+            <a:r>
+              <a:t>风险发现从事后变为事中，甚至事前预警</a:t>
             </a:r>
           </a:p>
         </p:txBody>
@@ -10596,7 +10731,7 @@
               </a:defRPr>
             </a:pPr>
             <a:r>
-              <a:t>知识沉淀</a:t>
+              <a:t>知识数字化</a:t>
             </a:r>
           </a:p>
         </p:txBody>
@@ -10634,7 +10769,7 @@
               </a:defRPr>
             </a:pPr>
             <a:r>
-              <a:t>每次AI分析解读都是财务知识的数字化积累</a:t>
+              <a:t>AI每次分析的解读都是可复用的知识资产</a:t>
             </a:r>
           </a:p>
           <a:p>
@@ -10649,7 +10784,37 @@
               </a:defRPr>
             </a:pPr>
             <a:r>
-              <a:t>降低对资深财务分析师的依赖</a:t>
+              <a:t>新人无需长时间学习即可获得专业数据分析能力</a:t>
+            </a:r>
+          </a:p>
+          <a:p>
+            <a:pPr>
+              <a:spcAft>
+                <a:spcPts val="600"/>
+              </a:spcAft>
+              <a:defRPr sz="1200">
+                <a:solidFill>
+                  <a:srgbClr val="334055"/>
+                </a:solidFill>
+              </a:defRPr>
+            </a:pPr>
+            <a:r>
+              <a:t>降低对资深财务分析师个人经验的依赖</a:t>
+            </a:r>
+          </a:p>
+          <a:p>
+            <a:pPr>
+              <a:spcAft>
+                <a:spcPts val="600"/>
+              </a:spcAft>
+              <a:defRPr sz="1200">
+                <a:solidFill>
+                  <a:srgbClr val="334055"/>
+                </a:solidFill>
+              </a:defRPr>
+            </a:pPr>
+            <a:r>
+              <a:t>企业数据分析和财务知识持续积累沉淀</a:t>
             </a:r>
           </a:p>
         </p:txBody>
@@ -11733,7 +11898,7 @@
               </a:defRPr>
             </a:pPr>
             <a:r>
-              <a:t>正视局限规划未来</a:t>
+              <a:t>正视当前局限，规划未来演进路线</a:t>
             </a:r>
           </a:p>
         </p:txBody>
@@ -11747,7 +11912,7 @@
         <p:spPr>
           <a:xfrm>
             <a:off x="914400" y="1554480"/>
-            <a:ext cx="4572000" cy="457200"/>
+            <a:ext cx="5029200" cy="457200"/>
           </a:xfrm>
           <a:prstGeom prst="rect">
             <a:avLst/>
@@ -11781,8 +11946,8 @@
         </p:nvSpPr>
         <p:spPr>
           <a:xfrm>
-            <a:off x="914400" y="2011680"/>
-            <a:ext cx="5029200" cy="2286000"/>
+            <a:off x="914400" y="2103120"/>
+            <a:ext cx="5029200" cy="3657600"/>
           </a:xfrm>
           <a:prstGeom prst="rect">
             <a:avLst/>
@@ -11797,46 +11962,121 @@
           <a:p>
             <a:pPr>
               <a:spcAft>
-                <a:spcPts val="800"/>
+                <a:spcPts val="500"/>
               </a:spcAft>
-              <a:defRPr sz="1100">
+              <a:defRPr sz="1000">
                 <a:solidFill>
                   <a:srgbClr val="334055"/>
                 </a:solidFill>
               </a:defRPr>
             </a:pPr>
             <a:r>
-              <a:t>/复杂多步推理准确率偏低</a:t>
+              <a:t>复杂多步推理准确率偏低: 涉及跨表嵌套查询时，</a:t>
             </a:r>
           </a:p>
           <a:p>
             <a:pPr>
               <a:spcAft>
-                <a:spcPts val="800"/>
+                <a:spcPts val="500"/>
               </a:spcAft>
-              <a:defRPr sz="1100">
+              <a:defRPr sz="1000">
                 <a:solidFill>
                   <a:srgbClr val="334055"/>
                 </a:solidFill>
               </a:defRPr>
             </a:pPr>
             <a:r>
-              <a:t>/模糊问题澄清能力有限</a:t>
+              <a:t>  AI有时难以正确分解步骤，需进一步优化Prompt策略</a:t>
             </a:r>
           </a:p>
           <a:p>
             <a:pPr>
               <a:spcAft>
-                <a:spcPts val="800"/>
+                <a:spcPts val="500"/>
               </a:spcAft>
-              <a:defRPr sz="1100">
+              <a:defRPr sz="1000">
                 <a:solidFill>
                   <a:srgbClr val="334055"/>
                 </a:solidFill>
               </a:defRPr>
             </a:pPr>
             <a:r>
-              <a:t>/模拟数据缺乏真实业务验证</a:t>
+              <a:t>模糊问题澄清能力有限: 用户输入过于简单时，</a:t>
+            </a:r>
+          </a:p>
+          <a:p>
+            <a:pPr>
+              <a:spcAft>
+                <a:spcPts val="500"/>
+              </a:spcAft>
+              <a:defRPr sz="1000">
+                <a:solidFill>
+                  <a:srgbClr val="334055"/>
+                </a:solidFill>
+              </a:defRPr>
+            </a:pPr>
+            <a:r>
+              <a:t>  系统无法像人类分析师一样主动追问确认口径</a:t>
+            </a:r>
+          </a:p>
+          <a:p>
+            <a:pPr>
+              <a:spcAft>
+                <a:spcPts val="500"/>
+              </a:spcAft>
+              <a:defRPr sz="1000">
+                <a:solidFill>
+                  <a:srgbClr val="334055"/>
+                </a:solidFill>
+              </a:defRPr>
+            </a:pPr>
+            <a:r>
+              <a:t>模拟数据局限性: 当前基于模拟企业数据验证，</a:t>
+            </a:r>
+          </a:p>
+          <a:p>
+            <a:pPr>
+              <a:spcAft>
+                <a:spcPts val="500"/>
+              </a:spcAft>
+              <a:defRPr sz="1000">
+                <a:solidFill>
+                  <a:srgbClr val="334055"/>
+                </a:solidFill>
+              </a:defRPr>
+            </a:pPr>
+            <a:r>
+              <a:t>  缺乏真实企业业务场景的多样性和复杂性测试</a:t>
+            </a:r>
+          </a:p>
+          <a:p>
+            <a:pPr>
+              <a:spcAft>
+                <a:spcPts val="500"/>
+              </a:spcAft>
+              <a:defRPr sz="1000">
+                <a:solidFill>
+                  <a:srgbClr val="334055"/>
+                </a:solidFill>
+              </a:defRPr>
+            </a:pPr>
+            <a:r>
+              <a:t>自定义数据Schema理解: 对用户上传的任意格式</a:t>
+            </a:r>
+          </a:p>
+          <a:p>
+            <a:pPr>
+              <a:spcAft>
+                <a:spcPts val="500"/>
+              </a:spcAft>
+              <a:defRPr sz="1000">
+                <a:solidFill>
+                  <a:srgbClr val="334055"/>
+                </a:solidFill>
+              </a:defRPr>
+            </a:pPr>
+            <a:r>
+              <a:t>  数据，字段语义识别和关联推断能力有待加强</a:t>
             </a:r>
           </a:p>
         </p:txBody>
@@ -11850,7 +12090,7 @@
         <p:spPr>
           <a:xfrm>
             <a:off x="6400800" y="1554480"/>
-            <a:ext cx="4572000" cy="457200"/>
+            <a:ext cx="5029200" cy="457200"/>
           </a:xfrm>
           <a:prstGeom prst="rect">
             <a:avLst/>
@@ -11884,8 +12124,8 @@
         </p:nvSpPr>
         <p:spPr>
           <a:xfrm>
-            <a:off x="6400800" y="2011680"/>
-            <a:ext cx="5029200" cy="4114800"/>
+            <a:off x="6400800" y="2103120"/>
+            <a:ext cx="5029200" cy="3657600"/>
           </a:xfrm>
           <a:prstGeom prst="rect">
             <a:avLst/>
@@ -11900,91 +12140,181 @@
           <a:p>
             <a:pPr>
               <a:spcAft>
-                <a:spcPts val="800"/>
+                <a:spcPts val="500"/>
               </a:spcAft>
-              <a:defRPr sz="1100">
+              <a:defRPr sz="1000">
                 <a:solidFill>
                   <a:srgbClr val="334055"/>
                 </a:solidFill>
               </a:defRPr>
             </a:pPr>
             <a:r>
-              <a:t>/Agent模式-多轮追问+自动拆解</a:t>
+              <a:t>Agent模式: 支持多轮追问、自动拆解复杂问题，</a:t>
             </a:r>
           </a:p>
           <a:p>
             <a:pPr>
               <a:spcAft>
-                <a:spcPts val="800"/>
+                <a:spcPts val="500"/>
               </a:spcAft>
-              <a:defRPr sz="1100">
+              <a:defRPr sz="1000">
                 <a:solidFill>
                   <a:srgbClr val="334055"/>
                 </a:solidFill>
               </a:defRPr>
             </a:pPr>
             <a:r>
-              <a:t>/预测能力-接入时序预测模型</a:t>
+              <a:t>  像人类分析师一样逐步深入挖掘数据</a:t>
             </a:r>
           </a:p>
           <a:p>
             <a:pPr>
               <a:spcAft>
-                <a:spcPts val="800"/>
+                <a:spcPts val="500"/>
               </a:spcAft>
-              <a:defRPr sz="1100">
+              <a:defRPr sz="1000">
                 <a:solidFill>
                   <a:srgbClr val="334055"/>
                 </a:solidFill>
               </a:defRPr>
             </a:pPr>
             <a:r>
-              <a:t>/知识库RAG-接入企业财务制度文档</a:t>
+              <a:t>预测分析: 接入时间序列预测模型，</a:t>
             </a:r>
           </a:p>
           <a:p>
             <a:pPr>
               <a:spcAft>
-                <a:spcPts val="800"/>
+                <a:spcPts val="500"/>
               </a:spcAft>
-              <a:defRPr sz="1100">
+              <a:defRPr sz="1000">
                 <a:solidFill>
                   <a:srgbClr val="334055"/>
                 </a:solidFill>
               </a:defRPr>
             </a:pPr>
             <a:r>
-              <a:t>/多模态输出-自动生成PPT简报</a:t>
+              <a:t>  从描述过去升级为预测未来趋势</a:t>
             </a:r>
           </a:p>
           <a:p>
             <a:pPr>
               <a:spcAft>
-                <a:spcPts val="800"/>
+                <a:spcPts val="500"/>
               </a:spcAft>
-              <a:defRPr sz="1100">
+              <a:defRPr sz="1000">
                 <a:solidFill>
                   <a:srgbClr val="334055"/>
                 </a:solidFill>
               </a:defRPr>
             </a:pPr>
             <a:r>
-              <a:t>/企业级部署-对接ERP/权限管理</a:t>
+              <a:t>知识库RAG: 接入企业财务制度和行业知识文档，</a:t>
             </a:r>
           </a:p>
           <a:p>
             <a:pPr>
               <a:spcAft>
-                <a:spcPts val="800"/>
+                <a:spcPts val="500"/>
               </a:spcAft>
-              <a:defRPr sz="1100">
+              <a:defRPr sz="1000">
                 <a:solidFill>
                   <a:srgbClr val="334055"/>
                 </a:solidFill>
               </a:defRPr>
             </a:pPr>
             <a:r>
-              <a:t>/私有化部署-数据不出企业</a:t>
+              <a:t>  让AI分析更贴合企业实际业务场景</a:t>
+            </a:r>
+          </a:p>
+          <a:p>
+            <a:pPr>
+              <a:spcAft>
+                <a:spcPts val="500"/>
+              </a:spcAft>
+              <a:defRPr sz="1000">
+                <a:solidFill>
+                  <a:srgbClr val="334055"/>
+                </a:solidFill>
+              </a:defRPr>
+            </a:pPr>
+            <a:r>
+              <a:t>多模态输出: 支持自动生成PPT简报和图文报告，</a:t>
+            </a:r>
+          </a:p>
+          <a:p>
+            <a:pPr>
+              <a:spcAft>
+                <a:spcPts val="500"/>
+              </a:spcAft>
+              <a:defRPr sz="1000">
+                <a:solidFill>
+                  <a:srgbClr val="334055"/>
+                </a:solidFill>
+              </a:defRPr>
+            </a:pPr>
+            <a:r>
+              <a:t>  将分析结果直接转换为管理层可用的汇报材料</a:t>
+            </a:r>
+          </a:p>
+          <a:p>
+            <a:pPr>
+              <a:spcAft>
+                <a:spcPts val="500"/>
+              </a:spcAft>
+              <a:defRPr sz="1000">
+                <a:solidFill>
+                  <a:srgbClr val="334055"/>
+                </a:solidFill>
+              </a:defRPr>
+            </a:pPr>
+            <a:r>
+              <a:t>企业级部署: 对接ERP系统实现实时数据同步，</a:t>
+            </a:r>
+          </a:p>
+          <a:p>
+            <a:pPr>
+              <a:spcAft>
+                <a:spcPts val="500"/>
+              </a:spcAft>
+              <a:defRPr sz="1000">
+                <a:solidFill>
+                  <a:srgbClr val="334055"/>
+                </a:solidFill>
+              </a:defRPr>
+            </a:pPr>
+            <a:r>
+              <a:t>  支持多用户权限管理和数据访问控制</a:t>
+            </a:r>
+          </a:p>
+          <a:p>
+            <a:pPr>
+              <a:spcAft>
+                <a:spcPts val="500"/>
+              </a:spcAft>
+              <a:defRPr sz="1000">
+                <a:solidFill>
+                  <a:srgbClr val="334055"/>
+                </a:solidFill>
+              </a:defRPr>
+            </a:pPr>
+            <a:r>
+              <a:t>私有化部署: 支持完全离线部署，</a:t>
+            </a:r>
+          </a:p>
+          <a:p>
+            <a:pPr>
+              <a:spcAft>
+                <a:spcPts val="500"/>
+              </a:spcAft>
+              <a:defRPr sz="1000">
+                <a:solidFill>
+                  <a:srgbClr val="334055"/>
+                </a:solidFill>
+              </a:defRPr>
+            </a:pPr>
+            <a:r>
+              <a:t>  敏感财务数据不出企业内网</a:t>
             </a:r>
           </a:p>
         </p:txBody>
@@ -15219,7 +15549,7 @@
         <p:spPr>
           <a:xfrm>
             <a:off x="731520" y="4206240"/>
-            <a:ext cx="3474720" cy="1463040"/>
+            <a:ext cx="3474720" cy="2011680"/>
           </a:xfrm>
           <a:prstGeom prst="roundRect">
             <a:avLst/>
@@ -15299,7 +15629,7 @@
         <p:spPr>
           <a:xfrm>
             <a:off x="1005840" y="4754879"/>
-            <a:ext cx="2926079" cy="731520"/>
+            <a:ext cx="2926079" cy="1280160"/>
           </a:xfrm>
           <a:prstGeom prst="rect">
             <a:avLst/>
@@ -15323,7 +15653,7 @@
               </a:defRPr>
             </a:pPr>
             <a:r>
-              <a:t>问数以天为单位</a:t>
+              <a:t>传统模式从提问到拿到数据需1-3天</a:t>
             </a:r>
           </a:p>
           <a:p>
@@ -15338,7 +15668,22 @@
               </a:defRPr>
             </a:pPr>
             <a:r>
-              <a:t>错过决策窗口</a:t>
+              <a:t>涉及多轮沟通、需求传递和手工制表</a:t>
+            </a:r>
+          </a:p>
+          <a:p>
+            <a:pPr>
+              <a:spcAft>
+                <a:spcPts val="400"/>
+              </a:spcAft>
+              <a:defRPr sz="1100">
+                <a:solidFill>
+                  <a:srgbClr val="334055"/>
+                </a:solidFill>
+              </a:defRPr>
+            </a:pPr>
+            <a:r>
+              <a:t>管理层往往错过最佳决策窗口</a:t>
             </a:r>
           </a:p>
         </p:txBody>
@@ -15352,7 +15697,7 @@
         <p:spPr>
           <a:xfrm>
             <a:off x="4572000" y="4206240"/>
-            <a:ext cx="3474720" cy="1463040"/>
+            <a:ext cx="3474720" cy="2011680"/>
           </a:xfrm>
           <a:prstGeom prst="roundRect">
             <a:avLst/>
@@ -15432,7 +15777,7 @@
         <p:spPr>
           <a:xfrm>
             <a:off x="4846320" y="4754879"/>
-            <a:ext cx="2926079" cy="731520"/>
+            <a:ext cx="2926079" cy="1280160"/>
           </a:xfrm>
           <a:prstGeom prst="rect">
             <a:avLst/>
@@ -15456,7 +15801,7 @@
               </a:defRPr>
             </a:pPr>
             <a:r>
-              <a:t>非技术人员无法自助</a:t>
+              <a:t>非技术人员必须通过BI部门才能查数据</a:t>
             </a:r>
           </a:p>
           <a:p>
@@ -15471,7 +15816,22 @@
               </a:defRPr>
             </a:pPr>
             <a:r>
-              <a:t>BI团队成为瓶颈</a:t>
+              <a:t>业务人员懂业务但不懂SQL无法自助</a:t>
+            </a:r>
+          </a:p>
+          <a:p>
+            <a:pPr>
+              <a:spcAft>
+                <a:spcPts val="400"/>
+              </a:spcAft>
+              <a:defRPr sz="1100">
+                <a:solidFill>
+                  <a:srgbClr val="334055"/>
+                </a:solidFill>
+              </a:defRPr>
+            </a:pPr>
+            <a:r>
+              <a:t>数据分析师大部分时间花在取数而非分析</a:t>
             </a:r>
           </a:p>
         </p:txBody>
@@ -15485,7 +15845,7 @@
         <p:spPr>
           <a:xfrm>
             <a:off x="8412480" y="4206240"/>
-            <a:ext cx="3474720" cy="1463040"/>
+            <a:ext cx="3474720" cy="2011680"/>
           </a:xfrm>
           <a:prstGeom prst="roundRect">
             <a:avLst/>
@@ -15565,7 +15925,7 @@
         <p:spPr>
           <a:xfrm>
             <a:off x="8686800" y="4754879"/>
-            <a:ext cx="2926079" cy="731520"/>
+            <a:ext cx="2926079" cy="1280160"/>
           </a:xfrm>
           <a:prstGeom prst="rect">
             <a:avLst/>
@@ -15589,7 +15949,7 @@
               </a:defRPr>
             </a:pPr>
             <a:r>
-              <a:t>只给数据不解读</a:t>
+              <a:t>传统BI只返回数据不提供业务解读</a:t>
             </a:r>
           </a:p>
           <a:p>
@@ -15604,7 +15964,22 @@
               </a:defRPr>
             </a:pPr>
             <a:r>
-              <a:t>异常靠人发现易遗漏</a:t>
+              <a:t>异常指标需要人工逐个排查才能发现</a:t>
+            </a:r>
+          </a:p>
+          <a:p>
+            <a:pPr>
+              <a:spcAft>
+                <a:spcPts val="400"/>
+              </a:spcAft>
+              <a:defRPr sz="1100">
+                <a:solidFill>
+                  <a:srgbClr val="334055"/>
+                </a:solidFill>
+              </a:defRPr>
+            </a:pPr>
+            <a:r>
+              <a:t>缺乏从数据到洞察到行动建议的闭环</a:t>
             </a:r>
           </a:p>
         </p:txBody>
@@ -15905,7 +16280,7 @@
         <p:spPr>
           <a:xfrm>
             <a:off x="914400" y="2103120"/>
-            <a:ext cx="4572000" cy="2286000"/>
+            <a:ext cx="4572000" cy="2743200"/>
           </a:xfrm>
           <a:prstGeom prst="rect">
             <a:avLst/>
@@ -15920,118 +16295,133 @@
           <a:p>
             <a:pPr>
               <a:spcAft>
-                <a:spcPts val="700"/>
+                <a:spcPts val="600"/>
               </a:spcAft>
-              <a:defRPr sz="1200">
+              <a:defRPr sz="1100">
                 <a:solidFill>
                   <a:srgbClr val="334055"/>
                 </a:solidFill>
               </a:defRPr>
             </a:pPr>
             <a:r>
-              <a:t>BI分析师/业务人员反复沟通</a:t>
+              <a:t>业务人员提出看数需求</a:t>
             </a:r>
           </a:p>
           <a:p>
             <a:pPr>
               <a:spcAft>
-                <a:spcPts val="700"/>
+                <a:spcPts val="600"/>
               </a:spcAft>
-              <a:defRPr sz="1200">
+              <a:defRPr sz="1100">
                 <a:solidFill>
                   <a:srgbClr val="334055"/>
                 </a:solidFill>
               </a:defRPr>
             </a:pPr>
             <a:r>
-              <a:t>手动编写SQL测试出报表</a:t>
+              <a:t>BI分析师沟通确认口径和维度</a:t>
             </a:r>
           </a:p>
           <a:p>
             <a:pPr>
               <a:spcAft>
-                <a:spcPts val="700"/>
+                <a:spcPts val="600"/>
               </a:spcAft>
-              <a:defRPr sz="1200">
+              <a:defRPr sz="1100">
                 <a:solidFill>
                   <a:srgbClr val="334055"/>
                 </a:solidFill>
               </a:defRPr>
             </a:pPr>
             <a:r>
-              <a:t>等待 1-3 天才能拿到数据</a:t>
+              <a:t>分析师手动编写SQL并验证数据</a:t>
             </a:r>
           </a:p>
           <a:p>
             <a:pPr>
               <a:spcAft>
-                <a:spcPts val="700"/>
+                <a:spcPts val="600"/>
               </a:spcAft>
-              <a:defRPr sz="1200">
+              <a:defRPr sz="1100">
                 <a:solidFill>
                   <a:srgbClr val="334055"/>
                 </a:solidFill>
               </a:defRPr>
             </a:pPr>
             <a:r>
-              <a:t>数据给了但为什么需自己分析</a:t>
+              <a:t>出报表反馈给业务人员</a:t>
             </a:r>
           </a:p>
           <a:p>
             <a:pPr>
               <a:spcAft>
-                <a:spcPts val="700"/>
+                <a:spcPts val="600"/>
               </a:spcAft>
-              <a:defRPr sz="1200">
+              <a:defRPr sz="1100">
                 <a:solidFill>
                   <a:srgbClr val="334055"/>
                 </a:solidFill>
               </a:defRPr>
             </a:pPr>
+            <a:r>
+              <a:t>前后耗时1-3天，错过决策时机</a:t>
+            </a:r>
           </a:p>
           <a:p>
             <a:pPr>
               <a:spcAft>
-                <a:spcPts val="700"/>
+                <a:spcPts val="600"/>
               </a:spcAft>
-              <a:defRPr sz="1200">
+              <a:defRPr sz="1100">
                 <a:solidFill>
                   <a:srgbClr val="334055"/>
                 </a:solidFill>
               </a:defRPr>
             </a:pPr>
-            <a:r>
-              <a:t>核心矛盾:</a:t>
-            </a:r>
           </a:p>
           <a:p>
             <a:pPr>
               <a:spcAft>
-                <a:spcPts val="700"/>
+                <a:spcPts val="600"/>
               </a:spcAft>
-              <a:defRPr sz="1200">
+              <a:defRPr sz="1100">
                 <a:solidFill>
                   <a:srgbClr val="334055"/>
                 </a:solidFill>
               </a:defRPr>
             </a:pPr>
             <a:r>
-              <a:t>懂业务的人不懂 SQL</a:t>
+              <a:t>根本矛盾: 懂业务的人不懂SQL</a:t>
             </a:r>
           </a:p>
           <a:p>
             <a:pPr>
               <a:spcAft>
-                <a:spcPts val="700"/>
+                <a:spcPts val="600"/>
               </a:spcAft>
-              <a:defRPr sz="1200">
+              <a:defRPr sz="1100">
                 <a:solidFill>
                   <a:srgbClr val="334055"/>
                 </a:solidFill>
               </a:defRPr>
             </a:pPr>
             <a:r>
-              <a:t>懂 SQL 的人不懂业务</a:t>
+              <a:t>懂SQL的人不理解业务场景</a:t>
+            </a:r>
+          </a:p>
+          <a:p>
+            <a:pPr>
+              <a:spcAft>
+                <a:spcPts val="600"/>
+              </a:spcAft>
+              <a:defRPr sz="1100">
+                <a:solidFill>
+                  <a:srgbClr val="334055"/>
+                </a:solidFill>
+              </a:defRPr>
+            </a:pPr>
+            <a:r>
+              <a:t>双方反复确认 → 效率低 + 易出错</a:t>
             </a:r>
           </a:p>
         </p:txBody>
@@ -16080,7 +16470,7 @@
         <p:spPr>
           <a:xfrm>
             <a:off x="6858000" y="2103120"/>
-            <a:ext cx="4572000" cy="2286000"/>
+            <a:ext cx="4572000" cy="2743200"/>
           </a:xfrm>
           <a:prstGeom prst="rect">
             <a:avLst/>
@@ -16095,118 +16485,133 @@
           <a:p>
             <a:pPr>
               <a:spcAft>
-                <a:spcPts val="700"/>
+                <a:spcPts val="600"/>
               </a:spcAft>
-              <a:defRPr sz="1200">
+              <a:defRPr sz="1100">
                 <a:solidFill>
                   <a:srgbClr val="334055"/>
                 </a:solidFill>
               </a:defRPr>
             </a:pPr>
             <a:r>
-              <a:t>自然语言输入 AI自动生成SQL</a:t>
+              <a:t>业务人员直接用自然语言输入问题</a:t>
             </a:r>
           </a:p>
           <a:p>
             <a:pPr>
               <a:spcAft>
-                <a:spcPts val="700"/>
+                <a:spcPts val="600"/>
               </a:spcAft>
-              <a:defRPr sz="1200">
+              <a:defRPr sz="1100">
                 <a:solidFill>
                   <a:srgbClr val="334055"/>
                 </a:solidFill>
               </a:defRPr>
             </a:pPr>
             <a:r>
-              <a:t>3-10秒返回:数据+图表+AI解读</a:t>
+              <a:t>AI自动理解语义并生成SQL查询语句</a:t>
             </a:r>
           </a:p>
           <a:p>
             <a:pPr>
               <a:spcAft>
-                <a:spcPts val="700"/>
+                <a:spcPts val="600"/>
               </a:spcAft>
-              <a:defRPr sz="1200">
+              <a:defRPr sz="1100">
                 <a:solidFill>
                   <a:srgbClr val="334055"/>
                 </a:solidFill>
               </a:defRPr>
             </a:pPr>
             <a:r>
-              <a:t>零门槛任何人都能自助问数</a:t>
+              <a:t>系统执行查询，3-10秒返回结果</a:t>
             </a:r>
           </a:p>
           <a:p>
             <a:pPr>
               <a:spcAft>
-                <a:spcPts val="700"/>
+                <a:spcPts val="600"/>
               </a:spcAft>
-              <a:defRPr sz="1200">
+              <a:defRPr sz="1100">
                 <a:solidFill>
                   <a:srgbClr val="334055"/>
                 </a:solidFill>
               </a:defRPr>
             </a:pPr>
             <a:r>
-              <a:t>AI自动标注异常+行动建议</a:t>
+              <a:t>自动附带数据表格、图表和经营分析解读</a:t>
             </a:r>
           </a:p>
           <a:p>
             <a:pPr>
               <a:spcAft>
-                <a:spcPts val="700"/>
+                <a:spcPts val="600"/>
               </a:spcAft>
-              <a:defRPr sz="1200">
+              <a:defRPr sz="1100">
                 <a:solidFill>
                   <a:srgbClr val="334055"/>
                 </a:solidFill>
               </a:defRPr>
             </a:pPr>
+            <a:r>
+              <a:t>异常指标自动标注，给出行动建议</a:t>
+            </a:r>
           </a:p>
           <a:p>
             <a:pPr>
               <a:spcAft>
-                <a:spcPts val="700"/>
+                <a:spcPts val="600"/>
               </a:spcAft>
-              <a:defRPr sz="1200">
+              <a:defRPr sz="1100">
                 <a:solidFill>
                   <a:srgbClr val="334055"/>
                 </a:solidFill>
               </a:defRPr>
             </a:pPr>
-            <a:r>
-              <a:t>AI = 财务翻译官</a:t>
-            </a:r>
           </a:p>
           <a:p>
             <a:pPr>
               <a:spcAft>
-                <a:spcPts val="700"/>
+                <a:spcPts val="600"/>
               </a:spcAft>
-              <a:defRPr sz="1200">
+              <a:defRPr sz="1100">
                 <a:solidFill>
                   <a:srgbClr val="334055"/>
                 </a:solidFill>
               </a:defRPr>
             </a:pPr>
             <a:r>
-              <a:t>业务语言 to 数据库语言</a:t>
+              <a:t>AI成为连接业务与数据的翻译官:</a:t>
             </a:r>
           </a:p>
           <a:p>
             <a:pPr>
               <a:spcAft>
-                <a:spcPts val="700"/>
+                <a:spcPts val="600"/>
               </a:spcAft>
-              <a:defRPr sz="1200">
+              <a:defRPr sz="1100">
                 <a:solidFill>
                   <a:srgbClr val="334055"/>
                 </a:solidFill>
               </a:defRPr>
             </a:pPr>
             <a:r>
-              <a:t>数据结果 to 分析洞察</a:t>
+              <a:t>自然语言 → SQL（业务翻译为技术）</a:t>
+            </a:r>
+          </a:p>
+          <a:p>
+            <a:pPr>
+              <a:spcAft>
+                <a:spcPts val="600"/>
+              </a:spcAft>
+              <a:defRPr sz="1100">
+                <a:solidFill>
+                  <a:srgbClr val="334055"/>
+                </a:solidFill>
+              </a:defRPr>
+            </a:pPr>
+            <a:r>
+              <a:t>查询结果 → 分析洞察（数据翻译为决策）</a:t>
             </a:r>
           </a:p>
         </p:txBody>

</xml_diff>